<commit_message>
Cap nhat 34 slide SU12+DIA12: mindmap kieu Mermaid oval+pill mau sac, QR anh that
- Slide so do tu duy moi: nut ROOT bo goc xanh, 4 nhanh oval mau Mermaid
  (tim #7C3AED, xanh #065F46, do #B91C1C, cam #B45309), la pill bo goc,
  duong noi co mau, thay the 4 hop vuong cu
- Slide cung co: nhung anh QR PNG that de HS quet bang dien thoai
- 15 slide Lich su 12 (Bai 1-11 + TH1-4) cap nhat day du
- 19 slide Dia li 12 (Bai 1-19) cap nhat day du

Co-Authored-By: Claude Sonnet 4.6 <noreply@anthropic.com>
</commit_message>
<xml_diff>
--- a/mon/dia_li/slide/lop12/Slide_DIALY12_Bài_10_TH_Báo_cáo_dân_cư_TT20.pptx
+++ b/mon/dia_li/slide/lop12/Slide_DIALY12_Bài_10_TH_Báo_cáo_dân_cư_TT20.pptx
@@ -12,6 +12,7 @@
     <p:sldId id="260" r:id="rId11"/>
     <p:sldId id="261" r:id="rId12"/>
     <p:sldId id="262" r:id="rId13"/>
+    <p:sldId id="263" r:id="rId14"/>
   </p:sldIdLst>
   <p:sldSz cx="12188952" cy="6858000" type="screen4x3"/>
   <p:notesSz cx="6858000" cy="9144000"/>
@@ -3688,7 +3689,7 @@
                 </a:solidFill>
                 <a:latin typeface="Calibri"/>
               </a:rPr>
-              <a:t>Vẽ tháp dân số và biểu đồ phân bố</a:t>
+              <a:t>Vẽ tháp dân số</a:t>
             </a:r>
           </a:p>
         </p:txBody>
@@ -3707,7 +3708,7 @@
     <p:bg>
       <p:bgPr>
         <a:solidFill>
-          <a:srgbClr val="FFFFFF"/>
+          <a:srgbClr val="F8F9FA"/>
         </a:solidFill>
         <a:effectLst/>
       </p:bgPr>
@@ -3727,8 +3728,8 @@
         </p:nvSpPr>
         <p:spPr>
           <a:xfrm>
-            <a:off x="274320" y="182880"/>
-            <a:ext cx="2011680" cy="502920"/>
+            <a:off x="0" y="0"/>
+            <a:ext cx="12188952" cy="621792"/>
           </a:xfrm>
           <a:prstGeom prst="rect">
             <a:avLst/>
@@ -3770,8 +3771,8 @@
         </p:nvSpPr>
         <p:spPr>
           <a:xfrm>
-            <a:off x="274320" y="182880"/>
-            <a:ext cx="2011680" cy="502920"/>
+            <a:off x="274320" y="64008"/>
+            <a:ext cx="4114800" cy="347472"/>
           </a:xfrm>
           <a:prstGeom prst="rect">
             <a:avLst/>
@@ -3782,6 +3783,95 @@
           <a:bodyPr wrap="square">
             <a:spAutoFit/>
           </a:bodyPr>
+          <a:lstStyle/>
+          <a:p>
+            <a:pPr algn="l"/>
+            <a:r>
+              <a:rPr sz="2000" b="1">
+                <a:solidFill>
+                  <a:srgbClr val="FFFFFF"/>
+                </a:solidFill>
+                <a:latin typeface="Arial"/>
+              </a:rPr>
+              <a:t>SO DO TU DUY</a:t>
+            </a:r>
+          </a:p>
+        </p:txBody>
+      </p:sp>
+      <p:sp>
+        <p:nvSpPr>
+          <p:cNvPr id="4" name="TextBox 3"/>
+          <p:cNvSpPr txBox="1"/>
+          <p:nvPr/>
+        </p:nvSpPr>
+        <p:spPr>
+          <a:xfrm>
+            <a:off x="4572000" y="64008"/>
+            <a:ext cx="7342632" cy="347472"/>
+          </a:xfrm>
+          <a:prstGeom prst="rect">
+            <a:avLst/>
+          </a:prstGeom>
+          <a:noFill/>
+        </p:spPr>
+        <p:txBody>
+          <a:bodyPr wrap="square">
+            <a:spAutoFit/>
+          </a:bodyPr>
+          <a:lstStyle/>
+          <a:p>
+            <a:pPr algn="l"/>
+            <a:r>
+              <a:rPr sz="1300" b="0">
+                <a:solidFill>
+                  <a:srgbClr val="FFFFFF"/>
+                </a:solidFill>
+                <a:latin typeface="Calibri"/>
+              </a:rPr>
+              <a:t>ĐỊA LÍ 12  |  Bài 10 (TH). Báo cáo dân cư</a:t>
+            </a:r>
+          </a:p>
+        </p:txBody>
+      </p:sp>
+      <p:sp>
+        <p:nvSpPr>
+          <p:cNvPr id="5" name="Rounded Rectangle 4"/>
+          <p:cNvSpPr/>
+          <p:nvPr/>
+        </p:nvSpPr>
+        <p:spPr>
+          <a:xfrm>
+            <a:off x="3808476" y="804672"/>
+            <a:ext cx="4572000" cy="640080"/>
+          </a:xfrm>
+          <a:prstGeom prst="roundRect">
+            <a:avLst/>
+          </a:prstGeom>
+          <a:solidFill>
+            <a:srgbClr val="1E40AF"/>
+          </a:solidFill>
+          <a:ln>
+            <a:solidFill>
+              <a:srgbClr val="1E40AF"/>
+            </a:solidFill>
+          </a:ln>
+        </p:spPr>
+        <p:style>
+          <a:lnRef idx="1">
+            <a:schemeClr val="accent1"/>
+          </a:lnRef>
+          <a:fillRef idx="3">
+            <a:schemeClr val="accent1"/>
+          </a:fillRef>
+          <a:effectRef idx="2">
+            <a:schemeClr val="accent1"/>
+          </a:effectRef>
+          <a:fontRef idx="minor">
+            <a:schemeClr val="lt1"/>
+          </a:fontRef>
+        </p:style>
+        <p:txBody>
+          <a:bodyPr rtlCol="0" anchor="ctr" wrap="none"/>
           <a:lstStyle/>
           <a:p>
             <a:pPr algn="ctr"/>
@@ -3792,65 +3882,67 @@
                 </a:solidFill>
                 <a:latin typeface="Arial"/>
               </a:rPr>
-              <a:t>ĐỀ BÀI – NỘI DUNG 1</a:t>
-            </a:r>
-          </a:p>
-        </p:txBody>
-      </p:sp>
-      <p:sp>
-        <p:nvSpPr>
-          <p:cNvPr id="4" name="TextBox 3"/>
-          <p:cNvSpPr txBox="1"/>
-          <p:nvPr/>
-        </p:nvSpPr>
-        <p:spPr>
-          <a:xfrm>
-            <a:off x="274320" y="777240"/>
-            <a:ext cx="11640312" cy="594360"/>
-          </a:xfrm>
-          <a:prstGeom prst="rect">
-            <a:avLst/>
-          </a:prstGeom>
-          <a:noFill/>
-        </p:spPr>
-        <p:txBody>
-          <a:bodyPr wrap="square">
-            <a:spAutoFit/>
-          </a:bodyPr>
-          <a:lstStyle/>
-          <a:p>
-            <a:pPr algn="l"/>
-            <a:r>
-              <a:rPr sz="2600" b="1">
-                <a:solidFill>
-                  <a:srgbClr val="1E40AF"/>
-                </a:solidFill>
-                <a:latin typeface="Arial"/>
-              </a:rPr>
-              <a:t>Kĩ năng vẽ tháp dân số</a:t>
-            </a:r>
-          </a:p>
-        </p:txBody>
-      </p:sp>
-      <p:sp>
-        <p:nvSpPr>
-          <p:cNvPr id="5" name="Rectangle 4"/>
+              <a:t>Bài 10 (TH). Báo cáo dân cư</a:t>
+            </a:r>
+          </a:p>
+        </p:txBody>
+      </p:sp>
+      <p:cxnSp>
+        <p:nvCxnSpPr>
+          <p:cNvPr id="6" name="Connector 5"/>
+          <p:cNvCxnSpPr/>
+          <p:nvPr/>
+        </p:nvCxnSpPr>
+        <p:spPr>
+          <a:xfrm flipH="1">
+            <a:off x="1412748.0" y="1124712.0"/>
+            <a:ext cx="4681728.0" cy="864108.0"/>
+          </a:xfrm>
+          <a:prstGeom prst="line">
+            <a:avLst/>
+          </a:prstGeom>
+          <a:ln w="22860">
+            <a:solidFill>
+              <a:srgbClr val="7C3AED"/>
+            </a:solidFill>
+          </a:ln>
+        </p:spPr>
+        <p:style>
+          <a:lnRef idx="2">
+            <a:schemeClr val="accent1"/>
+          </a:lnRef>
+          <a:fillRef idx="0">
+            <a:schemeClr val="accent1"/>
+          </a:fillRef>
+          <a:effectRef idx="1">
+            <a:schemeClr val="accent1"/>
+          </a:effectRef>
+          <a:fontRef idx="minor">
+            <a:schemeClr val="tx1"/>
+          </a:fontRef>
+        </p:style>
+      </p:cxnSp>
+      <p:sp>
+        <p:nvSpPr>
+          <p:cNvPr id="7" name="Oval 6"/>
           <p:cNvSpPr/>
           <p:nvPr/>
         </p:nvSpPr>
         <p:spPr>
           <a:xfrm>
-            <a:off x="274320" y="1417320"/>
-            <a:ext cx="11640312" cy="36576"/>
-          </a:xfrm>
-          <a:prstGeom prst="rect">
+            <a:off x="109728" y="1691640"/>
+            <a:ext cx="2606040" cy="594360"/>
+          </a:xfrm>
+          <a:prstGeom prst="ellipse">
             <a:avLst/>
           </a:prstGeom>
           <a:solidFill>
-            <a:srgbClr val="1E40AF"/>
+            <a:srgbClr val="7C3AED"/>
           </a:solidFill>
           <a:ln>
-            <a:noFill/>
+            <a:solidFill>
+              <a:srgbClr val="7C3AED"/>
+            </a:solidFill>
           </a:ln>
         </p:spPr>
         <p:style>
@@ -3868,71 +3960,78 @@
           </a:fontRef>
         </p:style>
         <p:txBody>
-          <a:bodyPr rtlCol="0" anchor="ctr"/>
+          <a:bodyPr rtlCol="0" anchor="ctr" wrap="square"/>
           <a:lstStyle/>
           <a:p>
             <a:pPr algn="ctr"/>
-          </a:p>
-        </p:txBody>
-      </p:sp>
-      <p:sp>
-        <p:nvSpPr>
-          <p:cNvPr id="6" name="TextBox 5"/>
-          <p:cNvSpPr txBox="1"/>
-          <p:nvPr/>
-        </p:nvSpPr>
-        <p:spPr>
-          <a:xfrm>
-            <a:off x="274320" y="1508760"/>
-            <a:ext cx="11640312" cy="3840480"/>
-          </a:xfrm>
-          <a:prstGeom prst="rect">
-            <a:avLst/>
-          </a:prstGeom>
-          <a:noFill/>
-        </p:spPr>
-        <p:txBody>
-          <a:bodyPr wrap="square">
-            <a:spAutoFit/>
-          </a:bodyPr>
-          <a:lstStyle/>
-          <a:p>
-            <a:pPr algn="l"/>
-            <a:r>
-              <a:rPr sz="2200" b="0">
+            <a:r>
+              <a:rPr sz="1300" b="1">
                 <a:solidFill>
-                  <a:srgbClr val="1E293B"/>
+                  <a:srgbClr val="FFFFFF"/>
                 </a:solidFill>
-                <a:latin typeface="Calibri"/>
+                <a:latin typeface="Arial"/>
               </a:rPr>
-              <a:t>Tháp dân số:
-• Trục ngang: % dân số nam (trái) / nữ (phải)
-• Trục đứng: nhóm tuổi (5 năm/nhóm)
-• Đọc: đáy rộng = trẻ; đáy hẹp = già; lệch trái/phải = giới tính
-Tháp VN 2023: đang chuyển từ trẻ → già (thắt eo phía dưới)</a:t>
-            </a:r>
-          </a:p>
-        </p:txBody>
-      </p:sp>
-      <p:sp>
-        <p:nvSpPr>
-          <p:cNvPr id="7" name="Rectangle 6"/>
+              <a:t>Tháp dân số</a:t>
+            </a:r>
+          </a:p>
+        </p:txBody>
+      </p:sp>
+      <p:cxnSp>
+        <p:nvCxnSpPr>
+          <p:cNvPr id="8" name="Connector 7"/>
+          <p:cNvCxnSpPr/>
+          <p:nvPr/>
+        </p:nvCxnSpPr>
+        <p:spPr>
+          <a:xfrm flipV="1">
+            <a:off x="1412748.0" y="1568196.0"/>
+            <a:ext cx="2839212.0" cy="420624.0"/>
+          </a:xfrm>
+          <a:prstGeom prst="line">
+            <a:avLst/>
+          </a:prstGeom>
+          <a:ln w="12700">
+            <a:solidFill>
+              <a:srgbClr val="7C3AED"/>
+            </a:solidFill>
+          </a:ln>
+        </p:spPr>
+        <p:style>
+          <a:lnRef idx="2">
+            <a:schemeClr val="accent1"/>
+          </a:lnRef>
+          <a:fillRef idx="0">
+            <a:schemeClr val="accent1"/>
+          </a:fillRef>
+          <a:effectRef idx="1">
+            <a:schemeClr val="accent1"/>
+          </a:effectRef>
+          <a:fontRef idx="minor">
+            <a:schemeClr val="tx1"/>
+          </a:fontRef>
+        </p:style>
+      </p:cxnSp>
+      <p:sp>
+        <p:nvSpPr>
+          <p:cNvPr id="9" name="Rounded Rectangle 8"/>
           <p:cNvSpPr/>
           <p:nvPr/>
         </p:nvSpPr>
         <p:spPr>
           <a:xfrm>
-            <a:off x="274320" y="5760720"/>
-            <a:ext cx="11640312" cy="685800"/>
-          </a:xfrm>
-          <a:prstGeom prst="rect">
+            <a:off x="2880360" y="1399032"/>
+            <a:ext cx="2743200" cy="338328"/>
+          </a:xfrm>
+          <a:prstGeom prst="roundRect">
             <a:avLst/>
           </a:prstGeom>
           <a:solidFill>
-            <a:srgbClr val="E0F2FE"/>
+            <a:srgbClr val="EDE9FE"/>
           </a:solidFill>
           <a:ln>
-            <a:noFill/>
+            <a:solidFill>
+              <a:srgbClr val="EDE9FE"/>
+            </a:solidFill>
           </a:ln>
         </p:spPr>
         <p:style>
@@ -3950,44 +4049,1264 @@
           </a:fontRef>
         </p:style>
         <p:txBody>
-          <a:bodyPr rtlCol="0" anchor="ctr"/>
-          <a:lstStyle/>
-          <a:p>
-            <a:pPr algn="ctr"/>
-          </a:p>
-        </p:txBody>
-      </p:sp>
-      <p:sp>
-        <p:nvSpPr>
-          <p:cNvPr id="8" name="TextBox 7"/>
-          <p:cNvSpPr txBox="1"/>
-          <p:nvPr/>
-        </p:nvSpPr>
-        <p:spPr>
-          <a:xfrm>
-            <a:off x="365760" y="5806440"/>
-            <a:ext cx="11457432" cy="594360"/>
-          </a:xfrm>
-          <a:prstGeom prst="rect">
-            <a:avLst/>
-          </a:prstGeom>
-          <a:noFill/>
-        </p:spPr>
-        <p:txBody>
-          <a:bodyPr wrap="square">
-            <a:spAutoFit/>
-          </a:bodyPr>
+          <a:bodyPr rtlCol="0" anchor="ctr" wrap="square"/>
           <a:lstStyle/>
           <a:p>
             <a:pPr algn="l"/>
             <a:r>
-              <a:rPr sz="1800" b="0">
+              <a:rPr sz="1200" b="0">
                 <a:solidFill>
-                  <a:srgbClr val="1E40AF"/>
+                  <a:srgbClr val="4C1D95"/>
                 </a:solidFill>
                 <a:latin typeface="Calibri"/>
               </a:rPr>
-              <a:t>💡 Suy nghĩ và thảo luận nhóm.</a:t>
+              <a:t>Trục hoành: % nam-nữ</a:t>
+            </a:r>
+          </a:p>
+        </p:txBody>
+      </p:sp>
+      <p:cxnSp>
+        <p:nvCxnSpPr>
+          <p:cNvPr id="10" name="Connector 9"/>
+          <p:cNvCxnSpPr/>
+          <p:nvPr/>
+        </p:nvCxnSpPr>
+        <p:spPr>
+          <a:xfrm>
+            <a:off x="1412748.0" y="1988820.0"/>
+            <a:ext cx="2839212.0" cy="0.0"/>
+          </a:xfrm>
+          <a:prstGeom prst="line">
+            <a:avLst/>
+          </a:prstGeom>
+          <a:ln w="12700">
+            <a:solidFill>
+              <a:srgbClr val="7C3AED"/>
+            </a:solidFill>
+          </a:ln>
+        </p:spPr>
+        <p:style>
+          <a:lnRef idx="2">
+            <a:schemeClr val="accent1"/>
+          </a:lnRef>
+          <a:fillRef idx="0">
+            <a:schemeClr val="accent1"/>
+          </a:fillRef>
+          <a:effectRef idx="1">
+            <a:schemeClr val="accent1"/>
+          </a:effectRef>
+          <a:fontRef idx="minor">
+            <a:schemeClr val="tx1"/>
+          </a:fontRef>
+        </p:style>
+      </p:cxnSp>
+      <p:sp>
+        <p:nvSpPr>
+          <p:cNvPr id="11" name="Rounded Rectangle 10"/>
+          <p:cNvSpPr/>
+          <p:nvPr/>
+        </p:nvSpPr>
+        <p:spPr>
+          <a:xfrm>
+            <a:off x="2880360" y="1819656"/>
+            <a:ext cx="2743200" cy="338328"/>
+          </a:xfrm>
+          <a:prstGeom prst="roundRect">
+            <a:avLst/>
+          </a:prstGeom>
+          <a:solidFill>
+            <a:srgbClr val="EDE9FE"/>
+          </a:solidFill>
+          <a:ln>
+            <a:solidFill>
+              <a:srgbClr val="EDE9FE"/>
+            </a:solidFill>
+          </a:ln>
+        </p:spPr>
+        <p:style>
+          <a:lnRef idx="1">
+            <a:schemeClr val="accent1"/>
+          </a:lnRef>
+          <a:fillRef idx="3">
+            <a:schemeClr val="accent1"/>
+          </a:fillRef>
+          <a:effectRef idx="2">
+            <a:schemeClr val="accent1"/>
+          </a:effectRef>
+          <a:fontRef idx="minor">
+            <a:schemeClr val="lt1"/>
+          </a:fontRef>
+        </p:style>
+        <p:txBody>
+          <a:bodyPr rtlCol="0" anchor="ctr" wrap="square"/>
+          <a:lstStyle/>
+          <a:p>
+            <a:pPr algn="l"/>
+            <a:r>
+              <a:rPr sz="1200" b="0">
+                <a:solidFill>
+                  <a:srgbClr val="4C1D95"/>
+                </a:solidFill>
+                <a:latin typeface="Calibri"/>
+              </a:rPr>
+              <a:t>Trục tung: nhóm tuổi</a:t>
+            </a:r>
+          </a:p>
+        </p:txBody>
+      </p:sp>
+      <p:cxnSp>
+        <p:nvCxnSpPr>
+          <p:cNvPr id="12" name="Connector 11"/>
+          <p:cNvCxnSpPr/>
+          <p:nvPr/>
+        </p:nvCxnSpPr>
+        <p:spPr>
+          <a:xfrm>
+            <a:off x="1412748.0" y="1988820.0"/>
+            <a:ext cx="2839212.0" cy="420624.0"/>
+          </a:xfrm>
+          <a:prstGeom prst="line">
+            <a:avLst/>
+          </a:prstGeom>
+          <a:ln w="12700">
+            <a:solidFill>
+              <a:srgbClr val="7C3AED"/>
+            </a:solidFill>
+          </a:ln>
+        </p:spPr>
+        <p:style>
+          <a:lnRef idx="2">
+            <a:schemeClr val="accent1"/>
+          </a:lnRef>
+          <a:fillRef idx="0">
+            <a:schemeClr val="accent1"/>
+          </a:fillRef>
+          <a:effectRef idx="1">
+            <a:schemeClr val="accent1"/>
+          </a:effectRef>
+          <a:fontRef idx="minor">
+            <a:schemeClr val="tx1"/>
+          </a:fontRef>
+        </p:style>
+      </p:cxnSp>
+      <p:sp>
+        <p:nvSpPr>
+          <p:cNvPr id="13" name="Rounded Rectangle 12"/>
+          <p:cNvSpPr/>
+          <p:nvPr/>
+        </p:nvSpPr>
+        <p:spPr>
+          <a:xfrm>
+            <a:off x="2880360" y="2240280"/>
+            <a:ext cx="2743200" cy="338328"/>
+          </a:xfrm>
+          <a:prstGeom prst="roundRect">
+            <a:avLst/>
+          </a:prstGeom>
+          <a:solidFill>
+            <a:srgbClr val="EDE9FE"/>
+          </a:solidFill>
+          <a:ln>
+            <a:solidFill>
+              <a:srgbClr val="EDE9FE"/>
+            </a:solidFill>
+          </a:ln>
+        </p:spPr>
+        <p:style>
+          <a:lnRef idx="1">
+            <a:schemeClr val="accent1"/>
+          </a:lnRef>
+          <a:fillRef idx="3">
+            <a:schemeClr val="accent1"/>
+          </a:fillRef>
+          <a:effectRef idx="2">
+            <a:schemeClr val="accent1"/>
+          </a:effectRef>
+          <a:fontRef idx="minor">
+            <a:schemeClr val="lt1"/>
+          </a:fontRef>
+        </p:style>
+        <p:txBody>
+          <a:bodyPr rtlCol="0" anchor="ctr" wrap="square"/>
+          <a:lstStyle/>
+          <a:p>
+            <a:pPr algn="l"/>
+            <a:r>
+              <a:rPr sz="1200" b="0">
+                <a:solidFill>
+                  <a:srgbClr val="4C1D95"/>
+                </a:solidFill>
+                <a:latin typeface="Calibri"/>
+              </a:rPr>
+              <a:t>Đọc hình dạng tháp</a:t>
+            </a:r>
+          </a:p>
+        </p:txBody>
+      </p:sp>
+      <p:cxnSp>
+        <p:nvCxnSpPr>
+          <p:cNvPr id="14" name="Connector 13"/>
+          <p:cNvCxnSpPr/>
+          <p:nvPr/>
+        </p:nvCxnSpPr>
+        <p:spPr>
+          <a:xfrm flipH="1">
+            <a:off x="1412748.0" y="1124712.0"/>
+            <a:ext cx="4681728.0" cy="3058668.0"/>
+          </a:xfrm>
+          <a:prstGeom prst="line">
+            <a:avLst/>
+          </a:prstGeom>
+          <a:ln w="22860">
+            <a:solidFill>
+              <a:srgbClr val="065F46"/>
+            </a:solidFill>
+          </a:ln>
+        </p:spPr>
+        <p:style>
+          <a:lnRef idx="2">
+            <a:schemeClr val="accent1"/>
+          </a:lnRef>
+          <a:fillRef idx="0">
+            <a:schemeClr val="accent1"/>
+          </a:fillRef>
+          <a:effectRef idx="1">
+            <a:schemeClr val="accent1"/>
+          </a:effectRef>
+          <a:fontRef idx="minor">
+            <a:schemeClr val="tx1"/>
+          </a:fontRef>
+        </p:style>
+      </p:cxnSp>
+      <p:sp>
+        <p:nvSpPr>
+          <p:cNvPr id="15" name="Oval 14"/>
+          <p:cNvSpPr/>
+          <p:nvPr/>
+        </p:nvSpPr>
+        <p:spPr>
+          <a:xfrm>
+            <a:off x="109728" y="3886200"/>
+            <a:ext cx="2606040" cy="594360"/>
+          </a:xfrm>
+          <a:prstGeom prst="ellipse">
+            <a:avLst/>
+          </a:prstGeom>
+          <a:solidFill>
+            <a:srgbClr val="065F46"/>
+          </a:solidFill>
+          <a:ln>
+            <a:solidFill>
+              <a:srgbClr val="065F46"/>
+            </a:solidFill>
+          </a:ln>
+        </p:spPr>
+        <p:style>
+          <a:lnRef idx="1">
+            <a:schemeClr val="accent1"/>
+          </a:lnRef>
+          <a:fillRef idx="3">
+            <a:schemeClr val="accent1"/>
+          </a:fillRef>
+          <a:effectRef idx="2">
+            <a:schemeClr val="accent1"/>
+          </a:effectRef>
+          <a:fontRef idx="minor">
+            <a:schemeClr val="lt1"/>
+          </a:fontRef>
+        </p:style>
+        <p:txBody>
+          <a:bodyPr rtlCol="0" anchor="ctr" wrap="square"/>
+          <a:lstStyle/>
+          <a:p>
+            <a:pPr algn="ctr"/>
+            <a:r>
+              <a:rPr sz="1300" b="1">
+                <a:solidFill>
+                  <a:srgbClr val="FFFFFF"/>
+                </a:solidFill>
+                <a:latin typeface="Arial"/>
+              </a:rPr>
+              <a:t>Phân tích tháp VN 2023</a:t>
+            </a:r>
+          </a:p>
+        </p:txBody>
+      </p:sp>
+      <p:cxnSp>
+        <p:nvCxnSpPr>
+          <p:cNvPr id="16" name="Connector 15"/>
+          <p:cNvCxnSpPr/>
+          <p:nvPr/>
+        </p:nvCxnSpPr>
+        <p:spPr>
+          <a:xfrm flipV="1">
+            <a:off x="1412748.0" y="3762756.0"/>
+            <a:ext cx="2839212.0" cy="420624.0"/>
+          </a:xfrm>
+          <a:prstGeom prst="line">
+            <a:avLst/>
+          </a:prstGeom>
+          <a:ln w="12700">
+            <a:solidFill>
+              <a:srgbClr val="065F46"/>
+            </a:solidFill>
+          </a:ln>
+        </p:spPr>
+        <p:style>
+          <a:lnRef idx="2">
+            <a:schemeClr val="accent1"/>
+          </a:lnRef>
+          <a:fillRef idx="0">
+            <a:schemeClr val="accent1"/>
+          </a:fillRef>
+          <a:effectRef idx="1">
+            <a:schemeClr val="accent1"/>
+          </a:effectRef>
+          <a:fontRef idx="minor">
+            <a:schemeClr val="tx1"/>
+          </a:fontRef>
+        </p:style>
+      </p:cxnSp>
+      <p:sp>
+        <p:nvSpPr>
+          <p:cNvPr id="17" name="Rounded Rectangle 16"/>
+          <p:cNvSpPr/>
+          <p:nvPr/>
+        </p:nvSpPr>
+        <p:spPr>
+          <a:xfrm>
+            <a:off x="2880360" y="3593592"/>
+            <a:ext cx="2743200" cy="338328"/>
+          </a:xfrm>
+          <a:prstGeom prst="roundRect">
+            <a:avLst/>
+          </a:prstGeom>
+          <a:solidFill>
+            <a:srgbClr val="D1FAE5"/>
+          </a:solidFill>
+          <a:ln>
+            <a:solidFill>
+              <a:srgbClr val="D1FAE5"/>
+            </a:solidFill>
+          </a:ln>
+        </p:spPr>
+        <p:style>
+          <a:lnRef idx="1">
+            <a:schemeClr val="accent1"/>
+          </a:lnRef>
+          <a:fillRef idx="3">
+            <a:schemeClr val="accent1"/>
+          </a:fillRef>
+          <a:effectRef idx="2">
+            <a:schemeClr val="accent1"/>
+          </a:effectRef>
+          <a:fontRef idx="minor">
+            <a:schemeClr val="lt1"/>
+          </a:fontRef>
+        </p:style>
+        <p:txBody>
+          <a:bodyPr rtlCol="0" anchor="ctr" wrap="square"/>
+          <a:lstStyle/>
+          <a:p>
+            <a:pPr algn="l"/>
+            <a:r>
+              <a:rPr sz="1200" b="0">
+                <a:solidFill>
+                  <a:srgbClr val="022C22"/>
+                </a:solidFill>
+                <a:latin typeface="Calibri"/>
+              </a:rPr>
+              <a:t>Đang già hóa</a:t>
+            </a:r>
+          </a:p>
+        </p:txBody>
+      </p:sp>
+      <p:cxnSp>
+        <p:nvCxnSpPr>
+          <p:cNvPr id="18" name="Connector 17"/>
+          <p:cNvCxnSpPr/>
+          <p:nvPr/>
+        </p:nvCxnSpPr>
+        <p:spPr>
+          <a:xfrm>
+            <a:off x="1412748.0" y="4183380.0"/>
+            <a:ext cx="2839212.0" cy="0.0"/>
+          </a:xfrm>
+          <a:prstGeom prst="line">
+            <a:avLst/>
+          </a:prstGeom>
+          <a:ln w="12700">
+            <a:solidFill>
+              <a:srgbClr val="065F46"/>
+            </a:solidFill>
+          </a:ln>
+        </p:spPr>
+        <p:style>
+          <a:lnRef idx="2">
+            <a:schemeClr val="accent1"/>
+          </a:lnRef>
+          <a:fillRef idx="0">
+            <a:schemeClr val="accent1"/>
+          </a:fillRef>
+          <a:effectRef idx="1">
+            <a:schemeClr val="accent1"/>
+          </a:effectRef>
+          <a:fontRef idx="minor">
+            <a:schemeClr val="tx1"/>
+          </a:fontRef>
+        </p:style>
+      </p:cxnSp>
+      <p:sp>
+        <p:nvSpPr>
+          <p:cNvPr id="19" name="Rounded Rectangle 18"/>
+          <p:cNvSpPr/>
+          <p:nvPr/>
+        </p:nvSpPr>
+        <p:spPr>
+          <a:xfrm>
+            <a:off x="2880360" y="4014216"/>
+            <a:ext cx="2743200" cy="338328"/>
+          </a:xfrm>
+          <a:prstGeom prst="roundRect">
+            <a:avLst/>
+          </a:prstGeom>
+          <a:solidFill>
+            <a:srgbClr val="D1FAE5"/>
+          </a:solidFill>
+          <a:ln>
+            <a:solidFill>
+              <a:srgbClr val="D1FAE5"/>
+            </a:solidFill>
+          </a:ln>
+        </p:spPr>
+        <p:style>
+          <a:lnRef idx="1">
+            <a:schemeClr val="accent1"/>
+          </a:lnRef>
+          <a:fillRef idx="3">
+            <a:schemeClr val="accent1"/>
+          </a:fillRef>
+          <a:effectRef idx="2">
+            <a:schemeClr val="accent1"/>
+          </a:effectRef>
+          <a:fontRef idx="minor">
+            <a:schemeClr val="lt1"/>
+          </a:fontRef>
+        </p:style>
+        <p:txBody>
+          <a:bodyPr rtlCol="0" anchor="ctr" wrap="square"/>
+          <a:lstStyle/>
+          <a:p>
+            <a:pPr algn="l"/>
+            <a:r>
+              <a:rPr sz="1200" b="0">
+                <a:solidFill>
+                  <a:srgbClr val="022C22"/>
+                </a:solidFill>
+                <a:latin typeface="Calibri"/>
+              </a:rPr>
+              <a:t>Tỉ lệ 60+ tăng nhanh</a:t>
+            </a:r>
+          </a:p>
+        </p:txBody>
+      </p:sp>
+      <p:cxnSp>
+        <p:nvCxnSpPr>
+          <p:cNvPr id="20" name="Connector 19"/>
+          <p:cNvCxnSpPr/>
+          <p:nvPr/>
+        </p:nvCxnSpPr>
+        <p:spPr>
+          <a:xfrm>
+            <a:off x="1412748.0" y="4183380.0"/>
+            <a:ext cx="2839212.0" cy="420624.0"/>
+          </a:xfrm>
+          <a:prstGeom prst="line">
+            <a:avLst/>
+          </a:prstGeom>
+          <a:ln w="12700">
+            <a:solidFill>
+              <a:srgbClr val="065F46"/>
+            </a:solidFill>
+          </a:ln>
+        </p:spPr>
+        <p:style>
+          <a:lnRef idx="2">
+            <a:schemeClr val="accent1"/>
+          </a:lnRef>
+          <a:fillRef idx="0">
+            <a:schemeClr val="accent1"/>
+          </a:fillRef>
+          <a:effectRef idx="1">
+            <a:schemeClr val="accent1"/>
+          </a:effectRef>
+          <a:fontRef idx="minor">
+            <a:schemeClr val="tx1"/>
+          </a:fontRef>
+        </p:style>
+      </p:cxnSp>
+      <p:sp>
+        <p:nvSpPr>
+          <p:cNvPr id="21" name="Rounded Rectangle 20"/>
+          <p:cNvSpPr/>
+          <p:nvPr/>
+        </p:nvSpPr>
+        <p:spPr>
+          <a:xfrm>
+            <a:off x="2880360" y="4434840"/>
+            <a:ext cx="2743200" cy="338328"/>
+          </a:xfrm>
+          <a:prstGeom prst="roundRect">
+            <a:avLst/>
+          </a:prstGeom>
+          <a:solidFill>
+            <a:srgbClr val="D1FAE5"/>
+          </a:solidFill>
+          <a:ln>
+            <a:solidFill>
+              <a:srgbClr val="D1FAE5"/>
+            </a:solidFill>
+          </a:ln>
+        </p:spPr>
+        <p:style>
+          <a:lnRef idx="1">
+            <a:schemeClr val="accent1"/>
+          </a:lnRef>
+          <a:fillRef idx="3">
+            <a:schemeClr val="accent1"/>
+          </a:fillRef>
+          <a:effectRef idx="2">
+            <a:schemeClr val="accent1"/>
+          </a:effectRef>
+          <a:fontRef idx="minor">
+            <a:schemeClr val="lt1"/>
+          </a:fontRef>
+        </p:style>
+        <p:txBody>
+          <a:bodyPr rtlCol="0" anchor="ctr" wrap="square"/>
+          <a:lstStyle/>
+          <a:p>
+            <a:pPr algn="l"/>
+            <a:r>
+              <a:rPr sz="1200" b="0">
+                <a:solidFill>
+                  <a:srgbClr val="022C22"/>
+                </a:solidFill>
+                <a:latin typeface="Calibri"/>
+              </a:rPr>
+              <a:t>Lực lượng LĐ vẫn lớn</a:t>
+            </a:r>
+          </a:p>
+        </p:txBody>
+      </p:sp>
+      <p:cxnSp>
+        <p:nvCxnSpPr>
+          <p:cNvPr id="22" name="Connector 21"/>
+          <p:cNvCxnSpPr/>
+          <p:nvPr/>
+        </p:nvCxnSpPr>
+        <p:spPr>
+          <a:xfrm>
+            <a:off x="6094476.0" y="1124712.0"/>
+            <a:ext cx="4681728.0" cy="864108.0"/>
+          </a:xfrm>
+          <a:prstGeom prst="line">
+            <a:avLst/>
+          </a:prstGeom>
+          <a:ln w="22860">
+            <a:solidFill>
+              <a:srgbClr val="B91C1C"/>
+            </a:solidFill>
+          </a:ln>
+        </p:spPr>
+        <p:style>
+          <a:lnRef idx="2">
+            <a:schemeClr val="accent1"/>
+          </a:lnRef>
+          <a:fillRef idx="0">
+            <a:schemeClr val="accent1"/>
+          </a:fillRef>
+          <a:effectRef idx="1">
+            <a:schemeClr val="accent1"/>
+          </a:effectRef>
+          <a:fontRef idx="minor">
+            <a:schemeClr val="tx1"/>
+          </a:fontRef>
+        </p:style>
+      </p:cxnSp>
+      <p:sp>
+        <p:nvSpPr>
+          <p:cNvPr id="23" name="Oval 22"/>
+          <p:cNvSpPr/>
+          <p:nvPr/>
+        </p:nvSpPr>
+        <p:spPr>
+          <a:xfrm>
+            <a:off x="9473184" y="1691640"/>
+            <a:ext cx="2606040" cy="594360"/>
+          </a:xfrm>
+          <a:prstGeom prst="ellipse">
+            <a:avLst/>
+          </a:prstGeom>
+          <a:solidFill>
+            <a:srgbClr val="B91C1C"/>
+          </a:solidFill>
+          <a:ln>
+            <a:solidFill>
+              <a:srgbClr val="B91C1C"/>
+            </a:solidFill>
+          </a:ln>
+        </p:spPr>
+        <p:style>
+          <a:lnRef idx="1">
+            <a:schemeClr val="accent1"/>
+          </a:lnRef>
+          <a:fillRef idx="3">
+            <a:schemeClr val="accent1"/>
+          </a:fillRef>
+          <a:effectRef idx="2">
+            <a:schemeClr val="accent1"/>
+          </a:effectRef>
+          <a:fontRef idx="minor">
+            <a:schemeClr val="lt1"/>
+          </a:fontRef>
+        </p:style>
+        <p:txBody>
+          <a:bodyPr rtlCol="0" anchor="ctr" wrap="square"/>
+          <a:lstStyle/>
+          <a:p>
+            <a:pPr algn="ctr"/>
+            <a:r>
+              <a:rPr sz="1300" b="1">
+                <a:solidFill>
+                  <a:srgbClr val="FFFFFF"/>
+                </a:solidFill>
+                <a:latin typeface="Arial"/>
+              </a:rPr>
+              <a:t>Biểu đồ dân số địa phương</a:t>
+            </a:r>
+          </a:p>
+        </p:txBody>
+      </p:sp>
+      <p:cxnSp>
+        <p:nvCxnSpPr>
+          <p:cNvPr id="24" name="Connector 23"/>
+          <p:cNvCxnSpPr/>
+          <p:nvPr/>
+        </p:nvCxnSpPr>
+        <p:spPr>
+          <a:xfrm flipH="1" flipV="1">
+            <a:off x="7936992.0" y="1568196.0"/>
+            <a:ext cx="2839212.0" cy="420624.0"/>
+          </a:xfrm>
+          <a:prstGeom prst="line">
+            <a:avLst/>
+          </a:prstGeom>
+          <a:ln w="12700">
+            <a:solidFill>
+              <a:srgbClr val="B91C1C"/>
+            </a:solidFill>
+          </a:ln>
+        </p:spPr>
+        <p:style>
+          <a:lnRef idx="2">
+            <a:schemeClr val="accent1"/>
+          </a:lnRef>
+          <a:fillRef idx="0">
+            <a:schemeClr val="accent1"/>
+          </a:fillRef>
+          <a:effectRef idx="1">
+            <a:schemeClr val="accent1"/>
+          </a:effectRef>
+          <a:fontRef idx="minor">
+            <a:schemeClr val="tx1"/>
+          </a:fontRef>
+        </p:style>
+      </p:cxnSp>
+      <p:sp>
+        <p:nvSpPr>
+          <p:cNvPr id="25" name="Rounded Rectangle 24"/>
+          <p:cNvSpPr/>
+          <p:nvPr/>
+        </p:nvSpPr>
+        <p:spPr>
+          <a:xfrm>
+            <a:off x="6565392" y="1399032"/>
+            <a:ext cx="2743200" cy="338328"/>
+          </a:xfrm>
+          <a:prstGeom prst="roundRect">
+            <a:avLst/>
+          </a:prstGeom>
+          <a:solidFill>
+            <a:srgbClr val="FEE2E2"/>
+          </a:solidFill>
+          <a:ln>
+            <a:solidFill>
+              <a:srgbClr val="FEE2E2"/>
+            </a:solidFill>
+          </a:ln>
+        </p:spPr>
+        <p:style>
+          <a:lnRef idx="1">
+            <a:schemeClr val="accent1"/>
+          </a:lnRef>
+          <a:fillRef idx="3">
+            <a:schemeClr val="accent1"/>
+          </a:fillRef>
+          <a:effectRef idx="2">
+            <a:schemeClr val="accent1"/>
+          </a:effectRef>
+          <a:fontRef idx="minor">
+            <a:schemeClr val="lt1"/>
+          </a:fontRef>
+        </p:style>
+        <p:txBody>
+          <a:bodyPr rtlCol="0" anchor="ctr" wrap="square"/>
+          <a:lstStyle/>
+          <a:p>
+            <a:pPr algn="l"/>
+            <a:r>
+              <a:rPr sz="1200" b="0">
+                <a:solidFill>
+                  <a:srgbClr val="450A0A"/>
+                </a:solidFill>
+                <a:latin typeface="Calibri"/>
+              </a:rPr>
+              <a:t>Dân số theo năm</a:t>
+            </a:r>
+          </a:p>
+        </p:txBody>
+      </p:sp>
+      <p:cxnSp>
+        <p:nvCxnSpPr>
+          <p:cNvPr id="26" name="Connector 25"/>
+          <p:cNvCxnSpPr/>
+          <p:nvPr/>
+        </p:nvCxnSpPr>
+        <p:spPr>
+          <a:xfrm flipH="1">
+            <a:off x="7936992.0" y="1988820.0"/>
+            <a:ext cx="2839212.0" cy="0.0"/>
+          </a:xfrm>
+          <a:prstGeom prst="line">
+            <a:avLst/>
+          </a:prstGeom>
+          <a:ln w="12700">
+            <a:solidFill>
+              <a:srgbClr val="B91C1C"/>
+            </a:solidFill>
+          </a:ln>
+        </p:spPr>
+        <p:style>
+          <a:lnRef idx="2">
+            <a:schemeClr val="accent1"/>
+          </a:lnRef>
+          <a:fillRef idx="0">
+            <a:schemeClr val="accent1"/>
+          </a:fillRef>
+          <a:effectRef idx="1">
+            <a:schemeClr val="accent1"/>
+          </a:effectRef>
+          <a:fontRef idx="minor">
+            <a:schemeClr val="tx1"/>
+          </a:fontRef>
+        </p:style>
+      </p:cxnSp>
+      <p:sp>
+        <p:nvSpPr>
+          <p:cNvPr id="27" name="Rounded Rectangle 26"/>
+          <p:cNvSpPr/>
+          <p:nvPr/>
+        </p:nvSpPr>
+        <p:spPr>
+          <a:xfrm>
+            <a:off x="6565392" y="1819656"/>
+            <a:ext cx="2743200" cy="338328"/>
+          </a:xfrm>
+          <a:prstGeom prst="roundRect">
+            <a:avLst/>
+          </a:prstGeom>
+          <a:solidFill>
+            <a:srgbClr val="FEE2E2"/>
+          </a:solidFill>
+          <a:ln>
+            <a:solidFill>
+              <a:srgbClr val="FEE2E2"/>
+            </a:solidFill>
+          </a:ln>
+        </p:spPr>
+        <p:style>
+          <a:lnRef idx="1">
+            <a:schemeClr val="accent1"/>
+          </a:lnRef>
+          <a:fillRef idx="3">
+            <a:schemeClr val="accent1"/>
+          </a:fillRef>
+          <a:effectRef idx="2">
+            <a:schemeClr val="accent1"/>
+          </a:effectRef>
+          <a:fontRef idx="minor">
+            <a:schemeClr val="lt1"/>
+          </a:fontRef>
+        </p:style>
+        <p:txBody>
+          <a:bodyPr rtlCol="0" anchor="ctr" wrap="square"/>
+          <a:lstStyle/>
+          <a:p>
+            <a:pPr algn="l"/>
+            <a:r>
+              <a:rPr sz="1200" b="0">
+                <a:solidFill>
+                  <a:srgbClr val="450A0A"/>
+                </a:solidFill>
+                <a:latin typeface="Calibri"/>
+              </a:rPr>
+              <a:t>Cơ cấu ĐT/NT</a:t>
+            </a:r>
+          </a:p>
+        </p:txBody>
+      </p:sp>
+      <p:cxnSp>
+        <p:nvCxnSpPr>
+          <p:cNvPr id="28" name="Connector 27"/>
+          <p:cNvCxnSpPr/>
+          <p:nvPr/>
+        </p:nvCxnSpPr>
+        <p:spPr>
+          <a:xfrm flipH="1">
+            <a:off x="7936992.0" y="1988820.0"/>
+            <a:ext cx="2839212.0" cy="420624.0"/>
+          </a:xfrm>
+          <a:prstGeom prst="line">
+            <a:avLst/>
+          </a:prstGeom>
+          <a:ln w="12700">
+            <a:solidFill>
+              <a:srgbClr val="B91C1C"/>
+            </a:solidFill>
+          </a:ln>
+        </p:spPr>
+        <p:style>
+          <a:lnRef idx="2">
+            <a:schemeClr val="accent1"/>
+          </a:lnRef>
+          <a:fillRef idx="0">
+            <a:schemeClr val="accent1"/>
+          </a:fillRef>
+          <a:effectRef idx="1">
+            <a:schemeClr val="accent1"/>
+          </a:effectRef>
+          <a:fontRef idx="minor">
+            <a:schemeClr val="tx1"/>
+          </a:fontRef>
+        </p:style>
+      </p:cxnSp>
+      <p:sp>
+        <p:nvSpPr>
+          <p:cNvPr id="29" name="Rounded Rectangle 28"/>
+          <p:cNvSpPr/>
+          <p:nvPr/>
+        </p:nvSpPr>
+        <p:spPr>
+          <a:xfrm>
+            <a:off x="6565392" y="2240280"/>
+            <a:ext cx="2743200" cy="338328"/>
+          </a:xfrm>
+          <a:prstGeom prst="roundRect">
+            <a:avLst/>
+          </a:prstGeom>
+          <a:solidFill>
+            <a:srgbClr val="FEE2E2"/>
+          </a:solidFill>
+          <a:ln>
+            <a:solidFill>
+              <a:srgbClr val="FEE2E2"/>
+            </a:solidFill>
+          </a:ln>
+        </p:spPr>
+        <p:style>
+          <a:lnRef idx="1">
+            <a:schemeClr val="accent1"/>
+          </a:lnRef>
+          <a:fillRef idx="3">
+            <a:schemeClr val="accent1"/>
+          </a:fillRef>
+          <a:effectRef idx="2">
+            <a:schemeClr val="accent1"/>
+          </a:effectRef>
+          <a:fontRef idx="minor">
+            <a:schemeClr val="lt1"/>
+          </a:fontRef>
+        </p:style>
+        <p:txBody>
+          <a:bodyPr rtlCol="0" anchor="ctr" wrap="square"/>
+          <a:lstStyle/>
+          <a:p>
+            <a:pPr algn="l"/>
+            <a:r>
+              <a:rPr sz="1200" b="0">
+                <a:solidFill>
+                  <a:srgbClr val="450A0A"/>
+                </a:solidFill>
+                <a:latin typeface="Calibri"/>
+              </a:rPr>
+              <a:t>So với cả nước</a:t>
+            </a:r>
+          </a:p>
+        </p:txBody>
+      </p:sp>
+      <p:cxnSp>
+        <p:nvCxnSpPr>
+          <p:cNvPr id="30" name="Connector 29"/>
+          <p:cNvCxnSpPr/>
+          <p:nvPr/>
+        </p:nvCxnSpPr>
+        <p:spPr>
+          <a:xfrm>
+            <a:off x="6094476.0" y="1124712.0"/>
+            <a:ext cx="4681728.0" cy="3058668.0"/>
+          </a:xfrm>
+          <a:prstGeom prst="line">
+            <a:avLst/>
+          </a:prstGeom>
+          <a:ln w="22860">
+            <a:solidFill>
+              <a:srgbClr val="B45309"/>
+            </a:solidFill>
+          </a:ln>
+        </p:spPr>
+        <p:style>
+          <a:lnRef idx="2">
+            <a:schemeClr val="accent1"/>
+          </a:lnRef>
+          <a:fillRef idx="0">
+            <a:schemeClr val="accent1"/>
+          </a:fillRef>
+          <a:effectRef idx="1">
+            <a:schemeClr val="accent1"/>
+          </a:effectRef>
+          <a:fontRef idx="minor">
+            <a:schemeClr val="tx1"/>
+          </a:fontRef>
+        </p:style>
+      </p:cxnSp>
+      <p:sp>
+        <p:nvSpPr>
+          <p:cNvPr id="31" name="Oval 30"/>
+          <p:cNvSpPr/>
+          <p:nvPr/>
+        </p:nvSpPr>
+        <p:spPr>
+          <a:xfrm>
+            <a:off x="9473184" y="3886200"/>
+            <a:ext cx="2606040" cy="594360"/>
+          </a:xfrm>
+          <a:prstGeom prst="ellipse">
+            <a:avLst/>
+          </a:prstGeom>
+          <a:solidFill>
+            <a:srgbClr val="B45309"/>
+          </a:solidFill>
+          <a:ln>
+            <a:solidFill>
+              <a:srgbClr val="B45309"/>
+            </a:solidFill>
+          </a:ln>
+        </p:spPr>
+        <p:style>
+          <a:lnRef idx="1">
+            <a:schemeClr val="accent1"/>
+          </a:lnRef>
+          <a:fillRef idx="3">
+            <a:schemeClr val="accent1"/>
+          </a:fillRef>
+          <a:effectRef idx="2">
+            <a:schemeClr val="accent1"/>
+          </a:effectRef>
+          <a:fontRef idx="minor">
+            <a:schemeClr val="lt1"/>
+          </a:fontRef>
+        </p:style>
+        <p:txBody>
+          <a:bodyPr rtlCol="0" anchor="ctr" wrap="square"/>
+          <a:lstStyle/>
+          <a:p>
+            <a:pPr algn="ctr"/>
+            <a:r>
+              <a:rPr sz="1300" b="1">
+                <a:solidFill>
+                  <a:srgbClr val="FFFFFF"/>
+                </a:solidFill>
+                <a:latin typeface="Arial"/>
+              </a:rPr>
+              <a:t>Liên hệ Bình Định</a:t>
+            </a:r>
+          </a:p>
+        </p:txBody>
+      </p:sp>
+      <p:cxnSp>
+        <p:nvCxnSpPr>
+          <p:cNvPr id="32" name="Connector 31"/>
+          <p:cNvCxnSpPr/>
+          <p:nvPr/>
+        </p:nvCxnSpPr>
+        <p:spPr>
+          <a:xfrm flipH="1" flipV="1">
+            <a:off x="7936992.0" y="3762756.0"/>
+            <a:ext cx="2839212.0" cy="420624.0"/>
+          </a:xfrm>
+          <a:prstGeom prst="line">
+            <a:avLst/>
+          </a:prstGeom>
+          <a:ln w="12700">
+            <a:solidFill>
+              <a:srgbClr val="B45309"/>
+            </a:solidFill>
+          </a:ln>
+        </p:spPr>
+        <p:style>
+          <a:lnRef idx="2">
+            <a:schemeClr val="accent1"/>
+          </a:lnRef>
+          <a:fillRef idx="0">
+            <a:schemeClr val="accent1"/>
+          </a:fillRef>
+          <a:effectRef idx="1">
+            <a:schemeClr val="accent1"/>
+          </a:effectRef>
+          <a:fontRef idx="minor">
+            <a:schemeClr val="tx1"/>
+          </a:fontRef>
+        </p:style>
+      </p:cxnSp>
+      <p:sp>
+        <p:nvSpPr>
+          <p:cNvPr id="33" name="Rounded Rectangle 32"/>
+          <p:cNvSpPr/>
+          <p:nvPr/>
+        </p:nvSpPr>
+        <p:spPr>
+          <a:xfrm>
+            <a:off x="6565392" y="3593592"/>
+            <a:ext cx="2743200" cy="338328"/>
+          </a:xfrm>
+          <a:prstGeom prst="roundRect">
+            <a:avLst/>
+          </a:prstGeom>
+          <a:solidFill>
+            <a:srgbClr val="FEF3C7"/>
+          </a:solidFill>
+          <a:ln>
+            <a:solidFill>
+              <a:srgbClr val="FEF3C7"/>
+            </a:solidFill>
+          </a:ln>
+        </p:spPr>
+        <p:style>
+          <a:lnRef idx="1">
+            <a:schemeClr val="accent1"/>
+          </a:lnRef>
+          <a:fillRef idx="3">
+            <a:schemeClr val="accent1"/>
+          </a:fillRef>
+          <a:effectRef idx="2">
+            <a:schemeClr val="accent1"/>
+          </a:effectRef>
+          <a:fontRef idx="minor">
+            <a:schemeClr val="lt1"/>
+          </a:fontRef>
+        </p:style>
+        <p:txBody>
+          <a:bodyPr rtlCol="0" anchor="ctr" wrap="square"/>
+          <a:lstStyle/>
+          <a:p>
+            <a:pPr algn="l"/>
+            <a:r>
+              <a:rPr sz="1200" b="0">
+                <a:solidFill>
+                  <a:srgbClr val="451A03"/>
+                </a:solidFill>
+                <a:latin typeface="Calibri"/>
+              </a:rPr>
+              <a:t>1,3 triệu dân</a:t>
+            </a:r>
+          </a:p>
+        </p:txBody>
+      </p:sp>
+      <p:cxnSp>
+        <p:nvCxnSpPr>
+          <p:cNvPr id="34" name="Connector 33"/>
+          <p:cNvCxnSpPr/>
+          <p:nvPr/>
+        </p:nvCxnSpPr>
+        <p:spPr>
+          <a:xfrm flipH="1">
+            <a:off x="7936992.0" y="4183380.0"/>
+            <a:ext cx="2839212.0" cy="0.0"/>
+          </a:xfrm>
+          <a:prstGeom prst="line">
+            <a:avLst/>
+          </a:prstGeom>
+          <a:ln w="12700">
+            <a:solidFill>
+              <a:srgbClr val="B45309"/>
+            </a:solidFill>
+          </a:ln>
+        </p:spPr>
+        <p:style>
+          <a:lnRef idx="2">
+            <a:schemeClr val="accent1"/>
+          </a:lnRef>
+          <a:fillRef idx="0">
+            <a:schemeClr val="accent1"/>
+          </a:fillRef>
+          <a:effectRef idx="1">
+            <a:schemeClr val="accent1"/>
+          </a:effectRef>
+          <a:fontRef idx="minor">
+            <a:schemeClr val="tx1"/>
+          </a:fontRef>
+        </p:style>
+      </p:cxnSp>
+      <p:sp>
+        <p:nvSpPr>
+          <p:cNvPr id="35" name="Rounded Rectangle 34"/>
+          <p:cNvSpPr/>
+          <p:nvPr/>
+        </p:nvSpPr>
+        <p:spPr>
+          <a:xfrm>
+            <a:off x="6565392" y="4014216"/>
+            <a:ext cx="2743200" cy="338328"/>
+          </a:xfrm>
+          <a:prstGeom prst="roundRect">
+            <a:avLst/>
+          </a:prstGeom>
+          <a:solidFill>
+            <a:srgbClr val="FEF3C7"/>
+          </a:solidFill>
+          <a:ln>
+            <a:solidFill>
+              <a:srgbClr val="FEF3C7"/>
+            </a:solidFill>
+          </a:ln>
+        </p:spPr>
+        <p:style>
+          <a:lnRef idx="1">
+            <a:schemeClr val="accent1"/>
+          </a:lnRef>
+          <a:fillRef idx="3">
+            <a:schemeClr val="accent1"/>
+          </a:fillRef>
+          <a:effectRef idx="2">
+            <a:schemeClr val="accent1"/>
+          </a:effectRef>
+          <a:fontRef idx="minor">
+            <a:schemeClr val="lt1"/>
+          </a:fontRef>
+        </p:style>
+        <p:txBody>
+          <a:bodyPr rtlCol="0" anchor="ctr" wrap="square"/>
+          <a:lstStyle/>
+          <a:p>
+            <a:pPr algn="l"/>
+            <a:r>
+              <a:rPr sz="1200" b="0">
+                <a:solidFill>
+                  <a:srgbClr val="451A03"/>
+                </a:solidFill>
+                <a:latin typeface="Calibri"/>
+              </a:rPr>
+              <a:t>ĐT hóa ~50%</a:t>
+            </a:r>
+          </a:p>
+        </p:txBody>
+      </p:sp>
+      <p:cxnSp>
+        <p:nvCxnSpPr>
+          <p:cNvPr id="36" name="Connector 35"/>
+          <p:cNvCxnSpPr/>
+          <p:nvPr/>
+        </p:nvCxnSpPr>
+        <p:spPr>
+          <a:xfrm flipH="1">
+            <a:off x="7936992.0" y="4183380.0"/>
+            <a:ext cx="2839212.0" cy="420624.0"/>
+          </a:xfrm>
+          <a:prstGeom prst="line">
+            <a:avLst/>
+          </a:prstGeom>
+          <a:ln w="12700">
+            <a:solidFill>
+              <a:srgbClr val="B45309"/>
+            </a:solidFill>
+          </a:ln>
+        </p:spPr>
+        <p:style>
+          <a:lnRef idx="2">
+            <a:schemeClr val="accent1"/>
+          </a:lnRef>
+          <a:fillRef idx="0">
+            <a:schemeClr val="accent1"/>
+          </a:fillRef>
+          <a:effectRef idx="1">
+            <a:schemeClr val="accent1"/>
+          </a:effectRef>
+          <a:fontRef idx="minor">
+            <a:schemeClr val="tx1"/>
+          </a:fontRef>
+        </p:style>
+      </p:cxnSp>
+      <p:sp>
+        <p:nvSpPr>
+          <p:cNvPr id="37" name="Rounded Rectangle 36"/>
+          <p:cNvSpPr/>
+          <p:nvPr/>
+        </p:nvSpPr>
+        <p:spPr>
+          <a:xfrm>
+            <a:off x="6565392" y="4434840"/>
+            <a:ext cx="2743200" cy="338328"/>
+          </a:xfrm>
+          <a:prstGeom prst="roundRect">
+            <a:avLst/>
+          </a:prstGeom>
+          <a:solidFill>
+            <a:srgbClr val="FEF3C7"/>
+          </a:solidFill>
+          <a:ln>
+            <a:solidFill>
+              <a:srgbClr val="FEF3C7"/>
+            </a:solidFill>
+          </a:ln>
+        </p:spPr>
+        <p:style>
+          <a:lnRef idx="1">
+            <a:schemeClr val="accent1"/>
+          </a:lnRef>
+          <a:fillRef idx="3">
+            <a:schemeClr val="accent1"/>
+          </a:fillRef>
+          <a:effectRef idx="2">
+            <a:schemeClr val="accent1"/>
+          </a:effectRef>
+          <a:fontRef idx="minor">
+            <a:schemeClr val="lt1"/>
+          </a:fontRef>
+        </p:style>
+        <p:txBody>
+          <a:bodyPr rtlCol="0" anchor="ctr" wrap="square"/>
+          <a:lstStyle/>
+          <a:p>
+            <a:pPr algn="l"/>
+            <a:r>
+              <a:rPr sz="1200" b="0">
+                <a:solidFill>
+                  <a:srgbClr val="451A03"/>
+                </a:solidFill>
+                <a:latin typeface="Calibri"/>
+              </a:rPr>
+              <a:t>Vĩnh Thạnh 25 000 người</a:t>
             </a:r>
           </a:p>
         </p:txBody>
@@ -4027,13 +5346,13 @@
         <p:spPr>
           <a:xfrm>
             <a:off x="274320" y="182880"/>
-            <a:ext cx="2286000" cy="502920"/>
+            <a:ext cx="2011680" cy="502920"/>
           </a:xfrm>
           <a:prstGeom prst="rect">
             <a:avLst/>
           </a:prstGeom>
           <a:solidFill>
-            <a:srgbClr val="991B1B"/>
+            <a:srgbClr val="1E40AF"/>
           </a:solidFill>
           <a:ln>
             <a:noFill/>
@@ -4070,7 +5389,7 @@
         <p:spPr>
           <a:xfrm>
             <a:off x="274320" y="182880"/>
-            <a:ext cx="2286000" cy="502920"/>
+            <a:ext cx="2011680" cy="502920"/>
           </a:xfrm>
           <a:prstGeom prst="rect">
             <a:avLst/>
@@ -4091,7 +5410,7 @@
                 </a:solidFill>
                 <a:latin typeface="Arial"/>
               </a:rPr>
-              <a:t>LỜI GIẢI – NỘI DUNG 1</a:t>
+              <a:t>ĐỀ BÀI – NỘI DUNG 1</a:t>
             </a:r>
           </a:p>
         </p:txBody>
@@ -4120,9 +5439,9 @@
           <a:p>
             <a:pPr algn="l"/>
             <a:r>
-              <a:rPr sz="2400" b="1">
+              <a:rPr sz="2600" b="1">
                 <a:solidFill>
-                  <a:srgbClr val="991B1B"/>
+                  <a:srgbClr val="1E40AF"/>
                 </a:solidFill>
                 <a:latin typeface="Arial"/>
               </a:rPr>
@@ -4146,7 +5465,7 @@
             <a:avLst/>
           </a:prstGeom>
           <a:solidFill>
-            <a:srgbClr val="991B1B"/>
+            <a:srgbClr val="1E40AF"/>
           </a:solidFill>
           <a:ln>
             <a:noFill/>
@@ -4183,7 +5502,7 @@
         <p:spPr>
           <a:xfrm>
             <a:off x="274320" y="1508760"/>
-            <a:ext cx="11640312" cy="3474720"/>
+            <a:ext cx="11640312" cy="3840480"/>
           </a:xfrm>
           <a:prstGeom prst="rect">
             <a:avLst/>
@@ -4198,17 +5517,15 @@
           <a:p>
             <a:pPr algn="l"/>
             <a:r>
-              <a:rPr sz="2100" b="0">
+              <a:rPr sz="2200" b="0">
                 <a:solidFill>
                   <a:srgbClr val="1E293B"/>
                 </a:solidFill>
                 <a:latin typeface="Calibri"/>
               </a:rPr>
-              <a:t>Tháp dân số:
-• Trục ngang: % dân số nam (trái) / nữ (phải)
-• Trục đứng: nhóm tuổi (5 năm/nhóm)
-• Đọc: đáy rộng = trẻ; đáy hẹp = già; lệch trái/phải = giới tính
-Tháp VN 2023: đang chuyển từ trẻ → già (thắt eo phía dưới)</a:t>
+              <a:t>Trục ngang: % nam (trái) / nữ (phải)
+Trục đứng: nhóm tuổi (5 năm/nhóm)
+Đọc: đáy rộng=trẻ; đáy hẹp=già; lệch=giới tính</a:t>
             </a:r>
           </a:p>
         </p:txBody>
@@ -4221,14 +5538,14 @@
         </p:nvSpPr>
         <p:spPr>
           <a:xfrm>
-            <a:off x="274320" y="5120640"/>
-            <a:ext cx="11640312" cy="914400"/>
+            <a:off x="274320" y="5760720"/>
+            <a:ext cx="11640312" cy="685800"/>
           </a:xfrm>
           <a:prstGeom prst="rect">
             <a:avLst/>
           </a:prstGeom>
           <a:solidFill>
-            <a:srgbClr val="FEF2F2"/>
+            <a:srgbClr val="E0F2FE"/>
           </a:solidFill>
           <a:ln>
             <a:noFill/>
@@ -4264,8 +5581,8 @@
         </p:nvSpPr>
         <p:spPr>
           <a:xfrm>
-            <a:off x="365760" y="5166360"/>
-            <a:ext cx="11457432" cy="822960"/>
+            <a:off x="365760" y="5806440"/>
+            <a:ext cx="11457432" cy="594360"/>
           </a:xfrm>
           <a:prstGeom prst="rect">
             <a:avLst/>
@@ -4280,13 +5597,13 @@
           <a:p>
             <a:pPr algn="l"/>
             <a:r>
-              <a:rPr sz="2200" b="1">
+              <a:rPr sz="1800" b="0">
                 <a:solidFill>
-                  <a:srgbClr val="991B1B"/>
+                  <a:srgbClr val="1E40AF"/>
                 </a:solidFill>
-                <a:latin typeface="Arial"/>
+                <a:latin typeface="Calibri"/>
               </a:rPr>
-              <a:t>✦ VN bước vào già hóa: tỉ lệ 60+ tăng nhanh</a:t>
+              <a:t>💡 Suy nghĩ và thảo luận nhóm.</a:t>
             </a:r>
           </a:p>
         </p:txBody>
@@ -4326,13 +5643,13 @@
         <p:spPr>
           <a:xfrm>
             <a:off x="274320" y="182880"/>
-            <a:ext cx="2011680" cy="502920"/>
+            <a:ext cx="2286000" cy="502920"/>
           </a:xfrm>
           <a:prstGeom prst="rect">
             <a:avLst/>
           </a:prstGeom>
           <a:solidFill>
-            <a:srgbClr val="1E40AF"/>
+            <a:srgbClr val="991B1B"/>
           </a:solidFill>
           <a:ln>
             <a:noFill/>
@@ -4369,7 +5686,7 @@
         <p:spPr>
           <a:xfrm>
             <a:off x="274320" y="182880"/>
-            <a:ext cx="2011680" cy="502920"/>
+            <a:ext cx="2286000" cy="502920"/>
           </a:xfrm>
           <a:prstGeom prst="rect">
             <a:avLst/>
@@ -4390,7 +5707,7 @@
                 </a:solidFill>
                 <a:latin typeface="Arial"/>
               </a:rPr>
-              <a:t>ĐỀ BÀI – NỘI DUNG 2</a:t>
+              <a:t>LỜI GIẢI – NỘI DUNG 1</a:t>
             </a:r>
           </a:p>
         </p:txBody>
@@ -4419,13 +5736,13 @@
           <a:p>
             <a:pPr algn="l"/>
             <a:r>
-              <a:rPr sz="2600" b="1">
+              <a:rPr sz="2400" b="1">
                 <a:solidFill>
-                  <a:srgbClr val="1E40AF"/>
+                  <a:srgbClr val="991B1B"/>
                 </a:solidFill>
                 <a:latin typeface="Arial"/>
               </a:rPr>
-              <a:t>Thực hành phân tích dân cư địa phương</a:t>
+              <a:t>Kĩ năng vẽ tháp dân số</a:t>
             </a:r>
           </a:p>
         </p:txBody>
@@ -4445,7 +5762,7 @@
             <a:avLst/>
           </a:prstGeom>
           <a:solidFill>
-            <a:srgbClr val="1E40AF"/>
+            <a:srgbClr val="991B1B"/>
           </a:solidFill>
           <a:ln>
             <a:noFill/>
@@ -4482,7 +5799,7 @@
         <p:spPr>
           <a:xfrm>
             <a:off x="274320" y="1508760"/>
-            <a:ext cx="11640312" cy="3840480"/>
+            <a:ext cx="11640312" cy="3474720"/>
           </a:xfrm>
           <a:prstGeom prst="rect">
             <a:avLst/>
@@ -4497,17 +5814,15 @@
           <a:p>
             <a:pPr algn="l"/>
             <a:r>
-              <a:rPr sz="2200" b="0">
+              <a:rPr sz="2100" b="0">
                 <a:solidFill>
                   <a:srgbClr val="1E293B"/>
                 </a:solidFill>
                 <a:latin typeface="Calibri"/>
               </a:rPr>
-              <a:t>Bước 1: Thu thập số liệu Niên giám Thống kê Bình Định
-Bước 2: Tính tỉ lệ đô thị/nông thôn, mật độ DS
-Bước 3: Vẽ biểu đồ cột thể hiện dân số qua các năm
-Bước 4: Nhận xét xu hướng, so sánh với cả nước
-Bước 5: Kết luận về đặc điểm dân cư Bình Định</a:t>
+              <a:t>Trục ngang: % nam (trái) / nữ (phải)
+Trục đứng: nhóm tuổi (5 năm/nhóm)
+Đọc: đáy rộng=trẻ; đáy hẹp=già; lệch=giới tính</a:t>
             </a:r>
           </a:p>
         </p:txBody>
@@ -4520,14 +5835,14 @@
         </p:nvSpPr>
         <p:spPr>
           <a:xfrm>
-            <a:off x="274320" y="5760720"/>
-            <a:ext cx="11640312" cy="685800"/>
+            <a:off x="274320" y="5120640"/>
+            <a:ext cx="11640312" cy="914400"/>
           </a:xfrm>
           <a:prstGeom prst="rect">
             <a:avLst/>
           </a:prstGeom>
           <a:solidFill>
-            <a:srgbClr val="E0F2FE"/>
+            <a:srgbClr val="FEF2F2"/>
           </a:solidFill>
           <a:ln>
             <a:noFill/>
@@ -4563,8 +5878,8 @@
         </p:nvSpPr>
         <p:spPr>
           <a:xfrm>
-            <a:off x="365760" y="5806440"/>
-            <a:ext cx="11457432" cy="594360"/>
+            <a:off x="365760" y="5166360"/>
+            <a:ext cx="11457432" cy="822960"/>
           </a:xfrm>
           <a:prstGeom prst="rect">
             <a:avLst/>
@@ -4579,13 +5894,13 @@
           <a:p>
             <a:pPr algn="l"/>
             <a:r>
-              <a:rPr sz="1800" b="0">
+              <a:rPr sz="2200" b="1">
                 <a:solidFill>
-                  <a:srgbClr val="1E40AF"/>
+                  <a:srgbClr val="991B1B"/>
                 </a:solidFill>
-                <a:latin typeface="Calibri"/>
+                <a:latin typeface="Arial"/>
               </a:rPr>
-              <a:t>💡 Suy nghĩ và thảo luận nhóm.</a:t>
+              <a:t>✦ VN 2023: đang chuyển từ trẻ → già (thắt eo dưới)</a:t>
             </a:r>
           </a:p>
         </p:txBody>
@@ -4625,13 +5940,13 @@
         <p:spPr>
           <a:xfrm>
             <a:off x="274320" y="182880"/>
-            <a:ext cx="2286000" cy="502920"/>
+            <a:ext cx="2011680" cy="502920"/>
           </a:xfrm>
           <a:prstGeom prst="rect">
             <a:avLst/>
           </a:prstGeom>
           <a:solidFill>
-            <a:srgbClr val="991B1B"/>
+            <a:srgbClr val="1E40AF"/>
           </a:solidFill>
           <a:ln>
             <a:noFill/>
@@ -4668,7 +5983,7 @@
         <p:spPr>
           <a:xfrm>
             <a:off x="274320" y="182880"/>
-            <a:ext cx="2286000" cy="502920"/>
+            <a:ext cx="2011680" cy="502920"/>
           </a:xfrm>
           <a:prstGeom prst="rect">
             <a:avLst/>
@@ -4689,7 +6004,7 @@
                 </a:solidFill>
                 <a:latin typeface="Arial"/>
               </a:rPr>
-              <a:t>LỜI GIẢI – NỘI DUNG 2</a:t>
+              <a:t>ĐỀ BÀI – NỘI DUNG 2</a:t>
             </a:r>
           </a:p>
         </p:txBody>
@@ -4718,13 +6033,13 @@
           <a:p>
             <a:pPr algn="l"/>
             <a:r>
-              <a:rPr sz="2400" b="1">
+              <a:rPr sz="2600" b="1">
                 <a:solidFill>
-                  <a:srgbClr val="991B1B"/>
+                  <a:srgbClr val="1E40AF"/>
                 </a:solidFill>
                 <a:latin typeface="Arial"/>
               </a:rPr>
-              <a:t>Thực hành phân tích dân cư địa phương</a:t>
+              <a:t>Thực hành địa phương</a:t>
             </a:r>
           </a:p>
         </p:txBody>
@@ -4744,7 +6059,7 @@
             <a:avLst/>
           </a:prstGeom>
           <a:solidFill>
-            <a:srgbClr val="991B1B"/>
+            <a:srgbClr val="1E40AF"/>
           </a:solidFill>
           <a:ln>
             <a:noFill/>
@@ -4781,7 +6096,7 @@
         <p:spPr>
           <a:xfrm>
             <a:off x="274320" y="1508760"/>
-            <a:ext cx="11640312" cy="3474720"/>
+            <a:ext cx="11640312" cy="3840480"/>
           </a:xfrm>
           <a:prstGeom prst="rect">
             <a:avLst/>
@@ -4796,17 +6111,16 @@
           <a:p>
             <a:pPr algn="l"/>
             <a:r>
-              <a:rPr sz="2100" b="0">
+              <a:rPr sz="2200" b="0">
                 <a:solidFill>
                   <a:srgbClr val="1E293B"/>
                 </a:solidFill>
                 <a:latin typeface="Calibri"/>
               </a:rPr>
-              <a:t>Bước 1: Thu thập số liệu Niên giám Thống kê Bình Định
-Bước 2: Tính tỉ lệ đô thị/nông thôn, mật độ DS
-Bước 3: Vẽ biểu đồ cột thể hiện dân số qua các năm
-Bước 4: Nhận xét xu hướng, so sánh với cả nước
-Bước 5: Kết luận về đặc điểm dân cư Bình Định</a:t>
+              <a:t>1. Số liệu Niên giám TK Bình Định
+2. Tỉ lệ đô thị/nông thôn, mật độ DS
+3. Biểu đồ cột DS qua các năm
+4. Nhận xét, kết luận</a:t>
             </a:r>
           </a:p>
         </p:txBody>
@@ -4819,14 +6133,14 @@
         </p:nvSpPr>
         <p:spPr>
           <a:xfrm>
-            <a:off x="274320" y="5120640"/>
-            <a:ext cx="11640312" cy="914400"/>
+            <a:off x="274320" y="5760720"/>
+            <a:ext cx="11640312" cy="685800"/>
           </a:xfrm>
           <a:prstGeom prst="rect">
             <a:avLst/>
           </a:prstGeom>
           <a:solidFill>
-            <a:srgbClr val="FEF2F2"/>
+            <a:srgbClr val="E0F2FE"/>
           </a:solidFill>
           <a:ln>
             <a:noFill/>
@@ -4862,8 +6176,8 @@
         </p:nvSpPr>
         <p:spPr>
           <a:xfrm>
-            <a:off x="365760" y="5166360"/>
-            <a:ext cx="11457432" cy="822960"/>
+            <a:off x="365760" y="5806440"/>
+            <a:ext cx="11457432" cy="594360"/>
           </a:xfrm>
           <a:prstGeom prst="rect">
             <a:avLst/>
@@ -4878,13 +6192,13 @@
           <a:p>
             <a:pPr algn="l"/>
             <a:r>
-              <a:rPr sz="2200" b="1">
+              <a:rPr sz="1800" b="0">
                 <a:solidFill>
-                  <a:srgbClr val="991B1B"/>
+                  <a:srgbClr val="1E40AF"/>
                 </a:solidFill>
-                <a:latin typeface="Arial"/>
+                <a:latin typeface="Calibri"/>
               </a:rPr>
-              <a:t>✦ Bình Định: 1,3 triệu dân; Vĩnh Thạnh: ~25 000 người</a:t>
+              <a:t>💡 Suy nghĩ và thảo luận nhóm.</a:t>
             </a:r>
           </a:p>
         </p:txBody>
@@ -4898,6 +6212,304 @@
 </file>
 
 <file path=ppt/slides/slide7.xml><?xml version="1.0" encoding="utf-8"?>
+<p:sld xmlns:a="http://schemas.openxmlformats.org/drawingml/2006/main" xmlns:p="http://schemas.openxmlformats.org/presentationml/2006/main" xmlns:r="http://schemas.openxmlformats.org/officeDocument/2006/relationships">
+  <p:cSld>
+    <p:bg>
+      <p:bgPr>
+        <a:solidFill>
+          <a:srgbClr val="FFFFFF"/>
+        </a:solidFill>
+        <a:effectLst/>
+      </p:bgPr>
+    </p:bg>
+    <p:spTree>
+      <p:nvGrpSpPr>
+        <p:cNvPr id="1" name=""/>
+        <p:cNvGrpSpPr/>
+        <p:nvPr/>
+      </p:nvGrpSpPr>
+      <p:grpSpPr/>
+      <p:sp>
+        <p:nvSpPr>
+          <p:cNvPr id="2" name="Rectangle 1"/>
+          <p:cNvSpPr/>
+          <p:nvPr/>
+        </p:nvSpPr>
+        <p:spPr>
+          <a:xfrm>
+            <a:off x="274320" y="182880"/>
+            <a:ext cx="2286000" cy="502920"/>
+          </a:xfrm>
+          <a:prstGeom prst="rect">
+            <a:avLst/>
+          </a:prstGeom>
+          <a:solidFill>
+            <a:srgbClr val="991B1B"/>
+          </a:solidFill>
+          <a:ln>
+            <a:noFill/>
+          </a:ln>
+        </p:spPr>
+        <p:style>
+          <a:lnRef idx="1">
+            <a:schemeClr val="accent1"/>
+          </a:lnRef>
+          <a:fillRef idx="3">
+            <a:schemeClr val="accent1"/>
+          </a:fillRef>
+          <a:effectRef idx="2">
+            <a:schemeClr val="accent1"/>
+          </a:effectRef>
+          <a:fontRef idx="minor">
+            <a:schemeClr val="lt1"/>
+          </a:fontRef>
+        </p:style>
+        <p:txBody>
+          <a:bodyPr rtlCol="0" anchor="ctr"/>
+          <a:lstStyle/>
+          <a:p>
+            <a:pPr algn="ctr"/>
+          </a:p>
+        </p:txBody>
+      </p:sp>
+      <p:sp>
+        <p:nvSpPr>
+          <p:cNvPr id="3" name="TextBox 2"/>
+          <p:cNvSpPr txBox="1"/>
+          <p:nvPr/>
+        </p:nvSpPr>
+        <p:spPr>
+          <a:xfrm>
+            <a:off x="274320" y="182880"/>
+            <a:ext cx="2286000" cy="502920"/>
+          </a:xfrm>
+          <a:prstGeom prst="rect">
+            <a:avLst/>
+          </a:prstGeom>
+          <a:noFill/>
+        </p:spPr>
+        <p:txBody>
+          <a:bodyPr wrap="square">
+            <a:spAutoFit/>
+          </a:bodyPr>
+          <a:lstStyle/>
+          <a:p>
+            <a:pPr algn="ctr"/>
+            <a:r>
+              <a:rPr sz="1600" b="1">
+                <a:solidFill>
+                  <a:srgbClr val="FFFFFF"/>
+                </a:solidFill>
+                <a:latin typeface="Arial"/>
+              </a:rPr>
+              <a:t>LỜI GIẢI – NỘI DUNG 2</a:t>
+            </a:r>
+          </a:p>
+        </p:txBody>
+      </p:sp>
+      <p:sp>
+        <p:nvSpPr>
+          <p:cNvPr id="4" name="TextBox 3"/>
+          <p:cNvSpPr txBox="1"/>
+          <p:nvPr/>
+        </p:nvSpPr>
+        <p:spPr>
+          <a:xfrm>
+            <a:off x="274320" y="777240"/>
+            <a:ext cx="11640312" cy="594360"/>
+          </a:xfrm>
+          <a:prstGeom prst="rect">
+            <a:avLst/>
+          </a:prstGeom>
+          <a:noFill/>
+        </p:spPr>
+        <p:txBody>
+          <a:bodyPr wrap="square">
+            <a:spAutoFit/>
+          </a:bodyPr>
+          <a:lstStyle/>
+          <a:p>
+            <a:pPr algn="l"/>
+            <a:r>
+              <a:rPr sz="2400" b="1">
+                <a:solidFill>
+                  <a:srgbClr val="991B1B"/>
+                </a:solidFill>
+                <a:latin typeface="Arial"/>
+              </a:rPr>
+              <a:t>Thực hành địa phương</a:t>
+            </a:r>
+          </a:p>
+        </p:txBody>
+      </p:sp>
+      <p:sp>
+        <p:nvSpPr>
+          <p:cNvPr id="5" name="Rectangle 4"/>
+          <p:cNvSpPr/>
+          <p:nvPr/>
+        </p:nvSpPr>
+        <p:spPr>
+          <a:xfrm>
+            <a:off x="274320" y="1417320"/>
+            <a:ext cx="11640312" cy="36576"/>
+          </a:xfrm>
+          <a:prstGeom prst="rect">
+            <a:avLst/>
+          </a:prstGeom>
+          <a:solidFill>
+            <a:srgbClr val="991B1B"/>
+          </a:solidFill>
+          <a:ln>
+            <a:noFill/>
+          </a:ln>
+        </p:spPr>
+        <p:style>
+          <a:lnRef idx="1">
+            <a:schemeClr val="accent1"/>
+          </a:lnRef>
+          <a:fillRef idx="3">
+            <a:schemeClr val="accent1"/>
+          </a:fillRef>
+          <a:effectRef idx="2">
+            <a:schemeClr val="accent1"/>
+          </a:effectRef>
+          <a:fontRef idx="minor">
+            <a:schemeClr val="lt1"/>
+          </a:fontRef>
+        </p:style>
+        <p:txBody>
+          <a:bodyPr rtlCol="0" anchor="ctr"/>
+          <a:lstStyle/>
+          <a:p>
+            <a:pPr algn="ctr"/>
+          </a:p>
+        </p:txBody>
+      </p:sp>
+      <p:sp>
+        <p:nvSpPr>
+          <p:cNvPr id="6" name="TextBox 5"/>
+          <p:cNvSpPr txBox="1"/>
+          <p:nvPr/>
+        </p:nvSpPr>
+        <p:spPr>
+          <a:xfrm>
+            <a:off x="274320" y="1508760"/>
+            <a:ext cx="11640312" cy="3474720"/>
+          </a:xfrm>
+          <a:prstGeom prst="rect">
+            <a:avLst/>
+          </a:prstGeom>
+          <a:noFill/>
+        </p:spPr>
+        <p:txBody>
+          <a:bodyPr wrap="square">
+            <a:spAutoFit/>
+          </a:bodyPr>
+          <a:lstStyle/>
+          <a:p>
+            <a:pPr algn="l"/>
+            <a:r>
+              <a:rPr sz="2100" b="0">
+                <a:solidFill>
+                  <a:srgbClr val="1E293B"/>
+                </a:solidFill>
+                <a:latin typeface="Calibri"/>
+              </a:rPr>
+              <a:t>1. Số liệu Niên giám TK Bình Định
+2. Tỉ lệ đô thị/nông thôn, mật độ DS
+3. Biểu đồ cột DS qua các năm
+4. Nhận xét, kết luận</a:t>
+            </a:r>
+          </a:p>
+        </p:txBody>
+      </p:sp>
+      <p:sp>
+        <p:nvSpPr>
+          <p:cNvPr id="7" name="Rectangle 6"/>
+          <p:cNvSpPr/>
+          <p:nvPr/>
+        </p:nvSpPr>
+        <p:spPr>
+          <a:xfrm>
+            <a:off x="274320" y="5120640"/>
+            <a:ext cx="11640312" cy="914400"/>
+          </a:xfrm>
+          <a:prstGeom prst="rect">
+            <a:avLst/>
+          </a:prstGeom>
+          <a:solidFill>
+            <a:srgbClr val="FEF2F2"/>
+          </a:solidFill>
+          <a:ln>
+            <a:noFill/>
+          </a:ln>
+        </p:spPr>
+        <p:style>
+          <a:lnRef idx="1">
+            <a:schemeClr val="accent1"/>
+          </a:lnRef>
+          <a:fillRef idx="3">
+            <a:schemeClr val="accent1"/>
+          </a:fillRef>
+          <a:effectRef idx="2">
+            <a:schemeClr val="accent1"/>
+          </a:effectRef>
+          <a:fontRef idx="minor">
+            <a:schemeClr val="lt1"/>
+          </a:fontRef>
+        </p:style>
+        <p:txBody>
+          <a:bodyPr rtlCol="0" anchor="ctr"/>
+          <a:lstStyle/>
+          <a:p>
+            <a:pPr algn="ctr"/>
+          </a:p>
+        </p:txBody>
+      </p:sp>
+      <p:sp>
+        <p:nvSpPr>
+          <p:cNvPr id="8" name="TextBox 7"/>
+          <p:cNvSpPr txBox="1"/>
+          <p:nvPr/>
+        </p:nvSpPr>
+        <p:spPr>
+          <a:xfrm>
+            <a:off x="365760" y="5166360"/>
+            <a:ext cx="11457432" cy="822960"/>
+          </a:xfrm>
+          <a:prstGeom prst="rect">
+            <a:avLst/>
+          </a:prstGeom>
+          <a:noFill/>
+        </p:spPr>
+        <p:txBody>
+          <a:bodyPr wrap="square">
+            <a:spAutoFit/>
+          </a:bodyPr>
+          <a:lstStyle/>
+          <a:p>
+            <a:pPr algn="l"/>
+            <a:r>
+              <a:rPr sz="2200" b="1">
+                <a:solidFill>
+                  <a:srgbClr val="991B1B"/>
+                </a:solidFill>
+                <a:latin typeface="Arial"/>
+              </a:rPr>
+              <a:t>✦ Bình Định: 1,3 triệu dân; Vĩnh Thạnh ~25 000</a:t>
+            </a:r>
+          </a:p>
+        </p:txBody>
+      </p:sp>
+    </p:spTree>
+  </p:cSld>
+  <p:clrMapOvr>
+    <a:masterClrMapping/>
+  </p:clrMapOvr>
+</p:sld>
+</file>
+
+<file path=ppt/slides/slide8.xml><?xml version="1.0" encoding="utf-8"?>
 <p:sld xmlns:a="http://schemas.openxmlformats.org/drawingml/2006/main" xmlns:p="http://schemas.openxmlformats.org/presentationml/2006/main" xmlns:r="http://schemas.openxmlformats.org/officeDocument/2006/relationships">
   <p:cSld>
     <p:bg>
@@ -5001,8 +6613,8 @@
         </p:nvSpPr>
         <p:spPr>
           <a:xfrm>
-            <a:off x="457200" y="1463040"/>
-            <a:ext cx="11274552" cy="640080"/>
+            <a:off x="365760" y="1417320"/>
+            <a:ext cx="6858000" cy="640080"/>
           </a:xfrm>
           <a:prstGeom prst="rect">
             <a:avLst/>
@@ -5015,9 +6627,9 @@
           </a:bodyPr>
           <a:lstStyle/>
           <a:p>
-            <a:pPr algn="ctr"/>
-            <a:r>
-              <a:rPr sz="2400" b="0">
+            <a:pPr algn="l"/>
+            <a:r>
+              <a:rPr sz="2200" b="0">
                 <a:solidFill>
                   <a:srgbClr val="1E40AF"/>
                 </a:solidFill>
@@ -5036,8 +6648,8 @@
         </p:nvSpPr>
         <p:spPr>
           <a:xfrm>
-            <a:off x="457200" y="2194560"/>
-            <a:ext cx="11274552" cy="731520"/>
+            <a:off x="365760" y="2103120"/>
+            <a:ext cx="6858000" cy="685800"/>
           </a:xfrm>
           <a:prstGeom prst="rect">
             <a:avLst/>
@@ -5079,8 +6691,8 @@
         </p:nvSpPr>
         <p:spPr>
           <a:xfrm>
-            <a:off x="548640" y="2240280"/>
-            <a:ext cx="11091672" cy="640080"/>
+            <a:off x="457200" y="2176272"/>
+            <a:ext cx="6675120" cy="548640"/>
           </a:xfrm>
           <a:prstGeom prst="rect">
             <a:avLst/>
@@ -5095,13 +6707,13 @@
           <a:p>
             <a:pPr algn="l"/>
             <a:r>
-              <a:rPr sz="2000" b="0">
+              <a:rPr sz="1700" b="0">
                 <a:solidFill>
                   <a:srgbClr val="15783A"/>
                 </a:solidFill>
                 <a:latin typeface="Calibri"/>
               </a:rPr>
-              <a:t>🔗 https://trangtu66.github.io/Taode_thi_online/dia_cc_bai10_k12.html</a:t>
+              <a:t>🔗  https://trangtu66.github.io/Taode_thi_online/dia_cc_bai10_k12.html</a:t>
             </a:r>
           </a:p>
         </p:txBody>
@@ -5114,8 +6726,8 @@
         </p:nvSpPr>
         <p:spPr>
           <a:xfrm>
-            <a:off x="457200" y="3108960"/>
-            <a:ext cx="11274552" cy="594360"/>
+            <a:off x="365760" y="2926080"/>
+            <a:ext cx="6858000" cy="822960"/>
           </a:xfrm>
           <a:prstGeom prst="rect">
             <a:avLst/>
@@ -5128,42 +6740,7 @@
           </a:bodyPr>
           <a:lstStyle/>
           <a:p>
-            <a:pPr algn="ctr"/>
-            <a:r>
-              <a:rPr sz="2200" b="0">
-                <a:solidFill>
-                  <a:srgbClr val="1E293B"/>
-                </a:solidFill>
-                <a:latin typeface="Calibri"/>
-              </a:rPr>
-              <a:t>Quét mã QR hoặc truy cập đường link để làm bài củng cố trực tuyến</a:t>
-            </a:r>
-          </a:p>
-        </p:txBody>
-      </p:sp>
-      <p:sp>
-        <p:nvSpPr>
-          <p:cNvPr id="8" name="TextBox 7"/>
-          <p:cNvSpPr txBox="1"/>
-          <p:nvPr/>
-        </p:nvSpPr>
-        <p:spPr>
-          <a:xfrm>
-            <a:off x="457200" y="3749039"/>
-            <a:ext cx="11274552" cy="548640"/>
-          </a:xfrm>
-          <a:prstGeom prst="rect">
-            <a:avLst/>
-          </a:prstGeom>
-          <a:noFill/>
-        </p:spPr>
-        <p:txBody>
-          <a:bodyPr wrap="square">
-            <a:spAutoFit/>
-          </a:bodyPr>
-          <a:lstStyle/>
-          <a:p>
-            <a:pPr algn="ctr"/>
+            <a:pPr algn="l"/>
             <a:r>
               <a:rPr sz="2000" b="0">
                 <a:solidFill>
@@ -5171,14 +6748,74 @@
                 </a:solidFill>
                 <a:latin typeface="Calibri"/>
               </a:rPr>
-              <a:t>📱 Làm bài trực tuyến – Kết quả ngay lập tức – Theo dõi tiến độ</a:t>
-            </a:r>
-          </a:p>
-        </p:txBody>
-      </p:sp>
-      <p:sp>
-        <p:nvSpPr>
-          <p:cNvPr id="9" name="Rectangle 8"/>
+              <a:t>6 câu trắc nghiệm + 1 câu đúng/sai
+Kết quả ngay lập tức – Xếp hạng lớp</a:t>
+            </a:r>
+          </a:p>
+        </p:txBody>
+      </p:sp>
+      <p:sp>
+        <p:nvSpPr>
+          <p:cNvPr id="8" name="TextBox 7"/>
+          <p:cNvSpPr txBox="1"/>
+          <p:nvPr/>
+        </p:nvSpPr>
+        <p:spPr>
+          <a:xfrm>
+            <a:off x="365760" y="3840480"/>
+            <a:ext cx="6858000" cy="548640"/>
+          </a:xfrm>
+          <a:prstGeom prst="rect">
+            <a:avLst/>
+          </a:prstGeom>
+          <a:noFill/>
+        </p:spPr>
+        <p:txBody>
+          <a:bodyPr wrap="square">
+            <a:spAutoFit/>
+          </a:bodyPr>
+          <a:lstStyle/>
+          <a:p>
+            <a:pPr algn="l"/>
+            <a:r>
+              <a:rPr sz="2200" b="1">
+                <a:solidFill>
+                  <a:srgbClr val="1E40AF"/>
+                </a:solidFill>
+                <a:latin typeface="Arial"/>
+              </a:rPr>
+              <a:t>📱  Quét mã QR để làm bài ngay →</a:t>
+            </a:r>
+          </a:p>
+        </p:txBody>
+      </p:sp>
+      <p:pic>
+        <p:nvPicPr>
+          <p:cNvPr id="9" name="Picture 8" descr="QR_CungCo_DIA12_Bai10.png"/>
+          <p:cNvPicPr>
+            <a:picLocks noChangeAspect="1"/>
+          </p:cNvPicPr>
+          <p:nvPr/>
+        </p:nvPicPr>
+        <p:blipFill>
+          <a:blip r:embed="rId2"/>
+          <a:stretch>
+            <a:fillRect/>
+          </a:stretch>
+        </p:blipFill>
+        <p:spPr>
+          <a:xfrm>
+            <a:off x="7589520" y="1280160"/>
+            <a:ext cx="4114800" cy="4114800"/>
+          </a:xfrm>
+          <a:prstGeom prst="rect">
+            <a:avLst/>
+          </a:prstGeom>
+        </p:spPr>
+      </p:pic>
+      <p:sp>
+        <p:nvSpPr>
+          <p:cNvPr id="10" name="Rectangle 9"/>
           <p:cNvSpPr/>
           <p:nvPr/>
         </p:nvSpPr>
@@ -5221,7 +6858,7 @@
       </p:sp>
       <p:sp>
         <p:nvSpPr>
-          <p:cNvPr id="10" name="TextBox 9"/>
+          <p:cNvPr id="11" name="TextBox 10"/>
           <p:cNvSpPr txBox="1"/>
           <p:nvPr/>
         </p:nvSpPr>

</xml_diff>

<commit_message>
Nang cap so do tu duy Premium va an danh hanh chinh cho toan bo KHBD/slide cu
- So do bong bong chuan moi (goc Navy #002060 chu in hoa trang; cap 1 #E2EFDA/#FFF2CC
  vien dam chu den dam; cap 2 pastel; khung tu co gian om chu, xuong dong 3-4 tu)
  cho Toan 10-11-12, Vat li 12, Lich su 12, Dia li 12, Hoa hoc 10, Ngu van 10-12, Sinh hoc 10-12
- Word: thay anh/bang so do cu; bai chua co so do duoc them so do + QR o cuoi file
- Slide: ve lai so do bang hinh khoi PowerPoint; bo Su 12 ban cu duoc chen slide so do o vi tri 4
- README: Mermaid co init htmlLabels/padding 10, bang mau Premium
- An danh: "Truong THPT", tac gia TTT, de trong ngay soan/ho ten GV, xoa khoi chu ky
- Noi dung cac hoat dong day hoc giu nguyen

Co-Authored-By: Claude Opus 5.5 <noreply@anthropic.com>
</commit_message>
<xml_diff>
--- a/mon/dia_li/slide/lop12/Slide_DIALY12_Bài_10_TH_Báo_cáo_dân_cư_TT20.pptx
+++ b/mon/dia_li/slide/lop12/Slide_DIALY12_Bài_10_TH_Báo_cáo_dân_cư_TT20.pptx
@@ -3176,7 +3176,7 @@
                 </a:solidFill>
                 <a:latin typeface="Arial"/>
               </a:rPr>
-              <a:t>TRƯỜNG THPT VĨNH THẠNH  |  ĐỊA LÍ 12  |  NĂM HỌC 2026–2027</a:t>
+              <a:t>TRƯỜNG THPT|  ĐỊA LÍ 12  |  NĂM HỌC 2026–2027</a:t>
             </a:r>
           </a:p>
         </p:txBody>
@@ -3281,7 +3281,7 @@
                 </a:solidFill>
                 <a:latin typeface="Calibri"/>
               </a:rPr>
-              <a:t>Giáo viên: Lê Thuỳ Dung</a:t>
+              <a:t>Giáo viên: ……………</a:t>
             </a:r>
           </a:p>
         </p:txBody>
@@ -3359,7 +3359,7 @@
                 </a:solidFill>
                 <a:latin typeface="Calibri"/>
               </a:rPr>
-              <a:t>Trường THPT Vĩnh Thạnh – Bình Định</a:t>
+              <a:t>Trường THPT – Bình Định</a:t>
             </a:r>
           </a:p>
         </p:txBody>
@@ -3793,7 +3793,7 @@
                 </a:solidFill>
                 <a:latin typeface="Arial"/>
               </a:rPr>
-              <a:t>SO DO TU DUY</a:t>
+              <a:t>SƠ ĐỒ TƯ DUY</a:t>
             </a:r>
           </a:p>
         </p:txBody>
@@ -3833,60 +3833,30 @@
           </a:p>
         </p:txBody>
       </p:sp>
-      <p:sp>
-        <p:nvSpPr>
-          <p:cNvPr id="5" name="Rounded Rectangle 4"/>
-          <p:cNvSpPr/>
-          <p:nvPr/>
-        </p:nvSpPr>
-        <p:spPr>
-          <a:xfrm>
-            <a:off x="3808476" y="804672"/>
-            <a:ext cx="4572000" cy="640080"/>
-          </a:xfrm>
-          <a:prstGeom prst="roundRect">
-            <a:avLst/>
-          </a:prstGeom>
-          <a:solidFill>
-            <a:srgbClr val="1E40AF"/>
-          </a:solidFill>
-          <a:ln>
-            <a:solidFill>
-              <a:srgbClr val="1E40AF"/>
-            </a:solidFill>
-          </a:ln>
-        </p:spPr>
-        <p:style>
-          <a:lnRef idx="1">
-            <a:schemeClr val="accent1"/>
-          </a:lnRef>
-          <a:fillRef idx="3">
-            <a:schemeClr val="accent1"/>
-          </a:fillRef>
-          <a:effectRef idx="2">
-            <a:schemeClr val="accent1"/>
-          </a:effectRef>
-          <a:fontRef idx="minor">
-            <a:schemeClr val="lt1"/>
-          </a:fontRef>
-        </p:style>
-        <p:txBody>
-          <a:bodyPr rtlCol="0" anchor="ctr" wrap="none"/>
-          <a:lstStyle/>
-          <a:p>
-            <a:pPr algn="ctr"/>
-            <a:r>
-              <a:rPr sz="1600" b="1">
-                <a:solidFill>
-                  <a:srgbClr val="FFFFFF"/>
-                </a:solidFill>
-                <a:latin typeface="Arial"/>
-              </a:rPr>
-              <a:t>Bài 10 (TH). Báo cáo dân cư</a:t>
-            </a:r>
-          </a:p>
-        </p:txBody>
-      </p:sp>
+      <p:pic>
+        <p:nvPicPr>
+          <p:cNvPr id="5" name="Picture 4" descr="_qr_dia_cc_bai10_k12.html.png"/>
+          <p:cNvPicPr>
+            <a:picLocks noChangeAspect="1"/>
+          </p:cNvPicPr>
+          <p:nvPr/>
+        </p:nvPicPr>
+        <p:blipFill>
+          <a:blip r:embed="rId2"/>
+          <a:stretch>
+            <a:fillRect/>
+          </a:stretch>
+        </p:blipFill>
+        <p:spPr>
+          <a:xfrm>
+            <a:off x="9674352" y="1463040"/>
+            <a:ext cx="2286000" cy="2286000"/>
+          </a:xfrm>
+          <a:prstGeom prst="rect">
+            <a:avLst/>
+          </a:prstGeom>
+        </p:spPr>
+      </p:pic>
       <p:cxnSp>
         <p:nvCxnSpPr>
           <p:cNvPr id="6" name="Connector 5"/>
@@ -3894,16 +3864,16 @@
           <p:nvPr/>
         </p:nvCxnSpPr>
         <p:spPr>
-          <a:xfrm flipH="1">
-            <a:off x="1412748.0" y="1124712.0"/>
-            <a:ext cx="4681728.0" cy="864108.0"/>
+          <a:xfrm flipH="1" flipV="1">
+            <a:off x="3508857" y="2670962"/>
+            <a:ext cx="1351179" cy="1283818"/>
           </a:xfrm>
           <a:prstGeom prst="line">
             <a:avLst/>
           </a:prstGeom>
-          <a:ln w="22860">
+          <a:ln w="44450">
             <a:solidFill>
-              <a:srgbClr val="7C3AED"/>
+              <a:srgbClr val="548235"/>
             </a:solidFill>
           </a:ln>
         </p:spPr>
@@ -3922,77 +3892,23 @@
           </a:fontRef>
         </p:style>
       </p:cxnSp>
-      <p:sp>
-        <p:nvSpPr>
-          <p:cNvPr id="7" name="Oval 6"/>
-          <p:cNvSpPr/>
-          <p:nvPr/>
-        </p:nvSpPr>
-        <p:spPr>
-          <a:xfrm>
-            <a:off x="109728" y="1691640"/>
-            <a:ext cx="2606040" cy="594360"/>
-          </a:xfrm>
-          <a:prstGeom prst="ellipse">
-            <a:avLst/>
-          </a:prstGeom>
-          <a:solidFill>
-            <a:srgbClr val="7C3AED"/>
-          </a:solidFill>
-          <a:ln>
-            <a:solidFill>
-              <a:srgbClr val="7C3AED"/>
-            </a:solidFill>
-          </a:ln>
-        </p:spPr>
-        <p:style>
-          <a:lnRef idx="1">
-            <a:schemeClr val="accent1"/>
-          </a:lnRef>
-          <a:fillRef idx="3">
-            <a:schemeClr val="accent1"/>
-          </a:fillRef>
-          <a:effectRef idx="2">
-            <a:schemeClr val="accent1"/>
-          </a:effectRef>
-          <a:fontRef idx="minor">
-            <a:schemeClr val="lt1"/>
-          </a:fontRef>
-        </p:style>
-        <p:txBody>
-          <a:bodyPr rtlCol="0" anchor="ctr" wrap="square"/>
-          <a:lstStyle/>
-          <a:p>
-            <a:pPr algn="ctr"/>
-            <a:r>
-              <a:rPr sz="1300" b="1">
-                <a:solidFill>
-                  <a:srgbClr val="FFFFFF"/>
-                </a:solidFill>
-                <a:latin typeface="Arial"/>
-              </a:rPr>
-              <a:t>Tháp dân số</a:t>
-            </a:r>
-          </a:p>
-        </p:txBody>
-      </p:sp>
       <p:cxnSp>
         <p:nvCxnSpPr>
-          <p:cNvPr id="8" name="Connector 7"/>
+          <p:cNvPr id="7" name="Connector 6"/>
           <p:cNvCxnSpPr/>
           <p:nvPr/>
         </p:nvCxnSpPr>
         <p:spPr>
-          <a:xfrm flipV="1">
-            <a:off x="1412748.0" y="1568196.0"/>
-            <a:ext cx="2839212.0" cy="420624.0"/>
+          <a:xfrm flipH="1" flipV="1">
+            <a:off x="2454940" y="2244872"/>
+            <a:ext cx="1053917" cy="426090"/>
           </a:xfrm>
           <a:prstGeom prst="line">
             <a:avLst/>
           </a:prstGeom>
-          <a:ln w="12700">
+          <a:ln w="15875">
             <a:solidFill>
-              <a:srgbClr val="7C3AED"/>
+              <a:srgbClr val="548235"/>
             </a:solidFill>
           </a:ln>
         </p:spPr>
@@ -4013,26 +3929,29 @@
       </p:cxnSp>
       <p:sp>
         <p:nvSpPr>
-          <p:cNvPr id="9" name="Rounded Rectangle 8"/>
+          <p:cNvPr id="8" name="Rounded Rectangle 7"/>
           <p:cNvSpPr/>
           <p:nvPr/>
         </p:nvSpPr>
         <p:spPr>
           <a:xfrm>
-            <a:off x="2880360" y="1399032"/>
-            <a:ext cx="2743200" cy="338328"/>
+            <a:off x="509239" y="2069271"/>
+            <a:ext cx="1945700" cy="351200"/>
           </a:xfrm>
           <a:prstGeom prst="roundRect">
-            <a:avLst/>
+            <a:avLst>
+              <a:gd name="adj" fmla="val 50000"/>
+            </a:avLst>
           </a:prstGeom>
           <a:solidFill>
-            <a:srgbClr val="EDE9FE"/>
+            <a:srgbClr val="EDF5E8"/>
           </a:solidFill>
-          <a:ln>
+          <a:ln w="15875">
             <a:solidFill>
-              <a:srgbClr val="EDE9FE"/>
+              <a:srgbClr val="548235"/>
             </a:solidFill>
           </a:ln>
+          <a:effectLst/>
         </p:spPr>
         <p:style>
           <a:lnRef idx="1">
@@ -4049,14 +3968,14 @@
           </a:fontRef>
         </p:style>
         <p:txBody>
-          <a:bodyPr rtlCol="0" anchor="ctr" wrap="square"/>
-          <a:lstStyle/>
-          <a:p>
-            <a:pPr algn="l"/>
-            <a:r>
-              <a:rPr sz="1200" b="0">
-                <a:solidFill>
-                  <a:srgbClr val="4C1D95"/>
+          <a:bodyPr rtlCol="0" anchor="ctr" wrap="none" lIns="64000" rIns="64000" tIns="25400" bIns="25400"/>
+          <a:lstStyle/>
+          <a:p>
+            <a:pPr algn="ctr"/>
+            <a:r>
+              <a:rPr sz="1300" b="0">
+                <a:solidFill>
+                  <a:srgbClr val="000000"/>
                 </a:solidFill>
                 <a:latin typeface="Calibri"/>
               </a:rPr>
@@ -4067,21 +3986,21 @@
       </p:sp>
       <p:cxnSp>
         <p:nvCxnSpPr>
-          <p:cNvPr id="10" name="Connector 9"/>
+          <p:cNvPr id="9" name="Connector 8"/>
           <p:cNvCxnSpPr/>
           <p:nvPr/>
         </p:nvCxnSpPr>
         <p:spPr>
-          <a:xfrm>
-            <a:off x="1412748.0" y="1988820.0"/>
-            <a:ext cx="2839212.0" cy="0.0"/>
+          <a:xfrm flipH="1">
+            <a:off x="2454940" y="2670962"/>
+            <a:ext cx="1053917" cy="0"/>
           </a:xfrm>
           <a:prstGeom prst="line">
             <a:avLst/>
           </a:prstGeom>
-          <a:ln w="12700">
+          <a:ln w="15875">
             <a:solidFill>
-              <a:srgbClr val="7C3AED"/>
+              <a:srgbClr val="548235"/>
             </a:solidFill>
           </a:ln>
         </p:spPr>
@@ -4102,26 +4021,29 @@
       </p:cxnSp>
       <p:sp>
         <p:nvSpPr>
-          <p:cNvPr id="11" name="Rounded Rectangle 10"/>
+          <p:cNvPr id="10" name="Rounded Rectangle 9"/>
           <p:cNvSpPr/>
           <p:nvPr/>
         </p:nvSpPr>
         <p:spPr>
           <a:xfrm>
-            <a:off x="2880360" y="1819656"/>
-            <a:ext cx="2743200" cy="338328"/>
+            <a:off x="509239" y="2495362"/>
+            <a:ext cx="1945700" cy="351200"/>
           </a:xfrm>
           <a:prstGeom prst="roundRect">
-            <a:avLst/>
+            <a:avLst>
+              <a:gd name="adj" fmla="val 50000"/>
+            </a:avLst>
           </a:prstGeom>
           <a:solidFill>
-            <a:srgbClr val="EDE9FE"/>
+            <a:srgbClr val="EDF5E8"/>
           </a:solidFill>
-          <a:ln>
+          <a:ln w="15875">
             <a:solidFill>
-              <a:srgbClr val="EDE9FE"/>
+              <a:srgbClr val="548235"/>
             </a:solidFill>
           </a:ln>
+          <a:effectLst/>
         </p:spPr>
         <p:style>
           <a:lnRef idx="1">
@@ -4138,14 +4060,14 @@
           </a:fontRef>
         </p:style>
         <p:txBody>
-          <a:bodyPr rtlCol="0" anchor="ctr" wrap="square"/>
-          <a:lstStyle/>
-          <a:p>
-            <a:pPr algn="l"/>
-            <a:r>
-              <a:rPr sz="1200" b="0">
-                <a:solidFill>
-                  <a:srgbClr val="4C1D95"/>
+          <a:bodyPr rtlCol="0" anchor="ctr" wrap="none" lIns="64000" rIns="64000" tIns="25400" bIns="25400"/>
+          <a:lstStyle/>
+          <a:p>
+            <a:pPr algn="ctr"/>
+            <a:r>
+              <a:rPr sz="1300" b="0">
+                <a:solidFill>
+                  <a:srgbClr val="000000"/>
                 </a:solidFill>
                 <a:latin typeface="Calibri"/>
               </a:rPr>
@@ -4156,21 +4078,21 @@
       </p:sp>
       <p:cxnSp>
         <p:nvCxnSpPr>
-          <p:cNvPr id="12" name="Connector 11"/>
+          <p:cNvPr id="11" name="Connector 10"/>
           <p:cNvCxnSpPr/>
           <p:nvPr/>
         </p:nvCxnSpPr>
         <p:spPr>
-          <a:xfrm>
-            <a:off x="1412748.0" y="1988820.0"/>
-            <a:ext cx="2839212.0" cy="420624.0"/>
+          <a:xfrm flipH="1">
+            <a:off x="2369088" y="2670962"/>
+            <a:ext cx="1139769" cy="426090"/>
           </a:xfrm>
           <a:prstGeom prst="line">
             <a:avLst/>
           </a:prstGeom>
-          <a:ln w="12700">
+          <a:ln w="15875">
             <a:solidFill>
-              <a:srgbClr val="7C3AED"/>
+              <a:srgbClr val="548235"/>
             </a:solidFill>
           </a:ln>
         </p:spPr>
@@ -4191,26 +4113,29 @@
       </p:cxnSp>
       <p:sp>
         <p:nvSpPr>
-          <p:cNvPr id="13" name="Rounded Rectangle 12"/>
+          <p:cNvPr id="12" name="Rounded Rectangle 11"/>
           <p:cNvSpPr/>
           <p:nvPr/>
         </p:nvSpPr>
         <p:spPr>
           <a:xfrm>
-            <a:off x="2880360" y="2240280"/>
-            <a:ext cx="2743200" cy="338328"/>
+            <a:off x="595091" y="2921452"/>
+            <a:ext cx="1773996" cy="351200"/>
           </a:xfrm>
           <a:prstGeom prst="roundRect">
-            <a:avLst/>
+            <a:avLst>
+              <a:gd name="adj" fmla="val 50000"/>
+            </a:avLst>
           </a:prstGeom>
           <a:solidFill>
-            <a:srgbClr val="EDE9FE"/>
+            <a:srgbClr val="EDF5E8"/>
           </a:solidFill>
-          <a:ln>
+          <a:ln w="15875">
             <a:solidFill>
-              <a:srgbClr val="EDE9FE"/>
+              <a:srgbClr val="548235"/>
             </a:solidFill>
           </a:ln>
+          <a:effectLst/>
         </p:spPr>
         <p:style>
           <a:lnRef idx="1">
@@ -4227,18 +4152,73 @@
           </a:fontRef>
         </p:style>
         <p:txBody>
-          <a:bodyPr rtlCol="0" anchor="ctr" wrap="square"/>
-          <a:lstStyle/>
-          <a:p>
-            <a:pPr algn="l"/>
-            <a:r>
-              <a:rPr sz="1200" b="0">
-                <a:solidFill>
-                  <a:srgbClr val="4C1D95"/>
+          <a:bodyPr rtlCol="0" anchor="ctr" wrap="none" lIns="64000" rIns="64000" tIns="25400" bIns="25400"/>
+          <a:lstStyle/>
+          <a:p>
+            <a:pPr algn="ctr"/>
+            <a:r>
+              <a:rPr sz="1300" b="0">
+                <a:solidFill>
+                  <a:srgbClr val="000000"/>
                 </a:solidFill>
                 <a:latin typeface="Calibri"/>
               </a:rPr>
               <a:t>Đọc hình dạng tháp</a:t>
+            </a:r>
+          </a:p>
+        </p:txBody>
+      </p:sp>
+      <p:sp>
+        <p:nvSpPr>
+          <p:cNvPr id="13" name="Oval 12"/>
+          <p:cNvSpPr/>
+          <p:nvPr/>
+        </p:nvSpPr>
+        <p:spPr>
+          <a:xfrm>
+            <a:off x="2631765" y="2427575"/>
+            <a:ext cx="1754184" cy="486773"/>
+          </a:xfrm>
+          <a:prstGeom prst="ellipse">
+            <a:avLst/>
+          </a:prstGeom>
+          <a:solidFill>
+            <a:srgbClr val="E2EFDA"/>
+          </a:solidFill>
+          <a:ln w="31750">
+            <a:solidFill>
+              <a:srgbClr val="375623"/>
+            </a:solidFill>
+          </a:ln>
+          <a:effectLst/>
+        </p:spPr>
+        <p:style>
+          <a:lnRef idx="1">
+            <a:schemeClr val="accent1"/>
+          </a:lnRef>
+          <a:fillRef idx="3">
+            <a:schemeClr val="accent1"/>
+          </a:fillRef>
+          <a:effectRef idx="2">
+            <a:schemeClr val="accent1"/>
+          </a:effectRef>
+          <a:fontRef idx="minor">
+            <a:schemeClr val="lt1"/>
+          </a:fontRef>
+        </p:style>
+        <p:txBody>
+          <a:bodyPr rtlCol="0" anchor="ctr" wrap="none" lIns="64000" rIns="64000" tIns="25400" bIns="25400"/>
+          <a:lstStyle/>
+          <a:p>
+            <a:pPr algn="ctr"/>
+            <a:r>
+              <a:rPr sz="1500" b="1">
+                <a:solidFill>
+                  <a:srgbClr val="000000"/>
+                </a:solidFill>
+                <a:latin typeface="Calibri"/>
+              </a:rPr>
+              <a:t>Tháp dân số</a:t>
             </a:r>
           </a:p>
         </p:txBody>
@@ -4250,16 +4230,16 @@
           <p:nvPr/>
         </p:nvCxnSpPr>
         <p:spPr>
-          <a:xfrm flipH="1">
-            <a:off x="1412748.0" y="1124712.0"/>
-            <a:ext cx="4681728.0" cy="3058668.0"/>
+          <a:xfrm flipV="1">
+            <a:off x="4860036" y="2670962"/>
+            <a:ext cx="1351178" cy="1283818"/>
           </a:xfrm>
           <a:prstGeom prst="line">
             <a:avLst/>
           </a:prstGeom>
-          <a:ln w="22860">
+          <a:ln w="44450">
             <a:solidFill>
-              <a:srgbClr val="065F46"/>
+              <a:srgbClr val="BF8F00"/>
             </a:solidFill>
           </a:ln>
         </p:spPr>
@@ -4278,77 +4258,23 @@
           </a:fontRef>
         </p:style>
       </p:cxnSp>
-      <p:sp>
-        <p:nvSpPr>
-          <p:cNvPr id="15" name="Oval 14"/>
-          <p:cNvSpPr/>
-          <p:nvPr/>
-        </p:nvSpPr>
-        <p:spPr>
-          <a:xfrm>
-            <a:off x="109728" y="3886200"/>
-            <a:ext cx="2606040" cy="594360"/>
-          </a:xfrm>
-          <a:prstGeom prst="ellipse">
-            <a:avLst/>
-          </a:prstGeom>
-          <a:solidFill>
-            <a:srgbClr val="065F46"/>
-          </a:solidFill>
-          <a:ln>
-            <a:solidFill>
-              <a:srgbClr val="065F46"/>
-            </a:solidFill>
-          </a:ln>
-        </p:spPr>
-        <p:style>
-          <a:lnRef idx="1">
-            <a:schemeClr val="accent1"/>
-          </a:lnRef>
-          <a:fillRef idx="3">
-            <a:schemeClr val="accent1"/>
-          </a:fillRef>
-          <a:effectRef idx="2">
-            <a:schemeClr val="accent1"/>
-          </a:effectRef>
-          <a:fontRef idx="minor">
-            <a:schemeClr val="lt1"/>
-          </a:fontRef>
-        </p:style>
-        <p:txBody>
-          <a:bodyPr rtlCol="0" anchor="ctr" wrap="square"/>
-          <a:lstStyle/>
-          <a:p>
-            <a:pPr algn="ctr"/>
-            <a:r>
-              <a:rPr sz="1300" b="1">
-                <a:solidFill>
-                  <a:srgbClr val="FFFFFF"/>
-                </a:solidFill>
-                <a:latin typeface="Arial"/>
-              </a:rPr>
-              <a:t>Phân tích tháp VN 2023</a:t>
-            </a:r>
-          </a:p>
-        </p:txBody>
-      </p:sp>
       <p:cxnSp>
         <p:nvCxnSpPr>
-          <p:cNvPr id="16" name="Connector 15"/>
+          <p:cNvPr id="15" name="Connector 14"/>
           <p:cNvCxnSpPr/>
           <p:nvPr/>
         </p:nvCxnSpPr>
         <p:spPr>
           <a:xfrm flipV="1">
-            <a:off x="1412748.0" y="3762756.0"/>
-            <a:ext cx="2839212.0" cy="420624.0"/>
+            <a:off x="6211214" y="2043450"/>
+            <a:ext cx="1397325" cy="627512"/>
           </a:xfrm>
           <a:prstGeom prst="line">
             <a:avLst/>
           </a:prstGeom>
-          <a:ln w="12700">
+          <a:ln w="15875">
             <a:solidFill>
-              <a:srgbClr val="065F46"/>
+              <a:srgbClr val="BF8F00"/>
             </a:solidFill>
           </a:ln>
         </p:spPr>
@@ -4369,26 +4295,29 @@
       </p:cxnSp>
       <p:sp>
         <p:nvSpPr>
-          <p:cNvPr id="17" name="Rounded Rectangle 16"/>
+          <p:cNvPr id="16" name="Rounded Rectangle 15"/>
           <p:cNvSpPr/>
           <p:nvPr/>
         </p:nvSpPr>
         <p:spPr>
           <a:xfrm>
-            <a:off x="2880360" y="3593592"/>
-            <a:ext cx="2743200" cy="338328"/>
+            <a:off x="7608539" y="1867849"/>
+            <a:ext cx="1258884" cy="351200"/>
           </a:xfrm>
           <a:prstGeom prst="roundRect">
-            <a:avLst/>
+            <a:avLst>
+              <a:gd name="adj" fmla="val 50000"/>
+            </a:avLst>
           </a:prstGeom>
           <a:solidFill>
-            <a:srgbClr val="D1FAE5"/>
+            <a:srgbClr val="FFF8E1"/>
           </a:solidFill>
-          <a:ln>
+          <a:ln w="15875">
             <a:solidFill>
-              <a:srgbClr val="D1FAE5"/>
+              <a:srgbClr val="BF8F00"/>
             </a:solidFill>
           </a:ln>
+          <a:effectLst/>
         </p:spPr>
         <p:style>
           <a:lnRef idx="1">
@@ -4405,14 +4334,14 @@
           </a:fontRef>
         </p:style>
         <p:txBody>
-          <a:bodyPr rtlCol="0" anchor="ctr" wrap="square"/>
-          <a:lstStyle/>
-          <a:p>
-            <a:pPr algn="l"/>
-            <a:r>
-              <a:rPr sz="1200" b="0">
-                <a:solidFill>
-                  <a:srgbClr val="022C22"/>
+          <a:bodyPr rtlCol="0" anchor="ctr" wrap="none" lIns="64000" rIns="64000" tIns="25400" bIns="25400"/>
+          <a:lstStyle/>
+          <a:p>
+            <a:pPr algn="ctr"/>
+            <a:r>
+              <a:rPr sz="1300" b="0">
+                <a:solidFill>
+                  <a:srgbClr val="000000"/>
                 </a:solidFill>
                 <a:latin typeface="Calibri"/>
               </a:rPr>
@@ -4423,21 +4352,21 @@
       </p:sp>
       <p:cxnSp>
         <p:nvCxnSpPr>
-          <p:cNvPr id="18" name="Connector 17"/>
+          <p:cNvPr id="17" name="Connector 16"/>
           <p:cNvCxnSpPr/>
           <p:nvPr/>
         </p:nvCxnSpPr>
         <p:spPr>
-          <a:xfrm>
-            <a:off x="1412748.0" y="4183380.0"/>
-            <a:ext cx="2839212.0" cy="0.0"/>
+          <a:xfrm flipV="1">
+            <a:off x="6211214" y="2570251"/>
+            <a:ext cx="1311473" cy="100711"/>
           </a:xfrm>
           <a:prstGeom prst="line">
             <a:avLst/>
           </a:prstGeom>
-          <a:ln w="12700">
+          <a:ln w="15875">
             <a:solidFill>
-              <a:srgbClr val="065F46"/>
+              <a:srgbClr val="BF8F00"/>
             </a:solidFill>
           </a:ln>
         </p:spPr>
@@ -4458,26 +4387,29 @@
       </p:cxnSp>
       <p:sp>
         <p:nvSpPr>
-          <p:cNvPr id="19" name="Rounded Rectangle 18"/>
+          <p:cNvPr id="18" name="Rounded Rectangle 17"/>
           <p:cNvSpPr/>
           <p:nvPr/>
         </p:nvSpPr>
         <p:spPr>
           <a:xfrm>
-            <a:off x="2880360" y="4014216"/>
-            <a:ext cx="2743200" cy="338328"/>
+            <a:off x="7522687" y="2293940"/>
+            <a:ext cx="1430588" cy="552622"/>
           </a:xfrm>
           <a:prstGeom prst="roundRect">
-            <a:avLst/>
+            <a:avLst>
+              <a:gd name="adj" fmla="val 50000"/>
+            </a:avLst>
           </a:prstGeom>
           <a:solidFill>
-            <a:srgbClr val="D1FAE5"/>
+            <a:srgbClr val="FFF8E1"/>
           </a:solidFill>
-          <a:ln>
+          <a:ln w="15875">
             <a:solidFill>
-              <a:srgbClr val="D1FAE5"/>
+              <a:srgbClr val="BF8F00"/>
             </a:solidFill>
           </a:ln>
+          <a:effectLst/>
         </p:spPr>
         <p:style>
           <a:lnRef idx="1">
@@ -4494,39 +4426,51 @@
           </a:fontRef>
         </p:style>
         <p:txBody>
-          <a:bodyPr rtlCol="0" anchor="ctr" wrap="square"/>
-          <a:lstStyle/>
-          <a:p>
-            <a:pPr algn="l"/>
-            <a:r>
-              <a:rPr sz="1200" b="0">
-                <a:solidFill>
-                  <a:srgbClr val="022C22"/>
+          <a:bodyPr rtlCol="0" anchor="ctr" wrap="none" lIns="64000" rIns="64000" tIns="25400" bIns="25400"/>
+          <a:lstStyle/>
+          <a:p>
+            <a:pPr algn="ctr"/>
+            <a:r>
+              <a:rPr sz="1300" b="0">
+                <a:solidFill>
+                  <a:srgbClr val="000000"/>
                 </a:solidFill>
                 <a:latin typeface="Calibri"/>
               </a:rPr>
-              <a:t>Tỉ lệ 60+ tăng nhanh</a:t>
+              <a:t>Tỉ lệ 60+ tăng</a:t>
+            </a:r>
+          </a:p>
+          <a:p>
+            <a:pPr algn="ctr"/>
+            <a:r>
+              <a:rPr sz="1300" b="0">
+                <a:solidFill>
+                  <a:srgbClr val="000000"/>
+                </a:solidFill>
+                <a:latin typeface="Calibri"/>
+              </a:rPr>
+              <a:t>nhanh</a:t>
             </a:r>
           </a:p>
         </p:txBody>
       </p:sp>
       <p:cxnSp>
         <p:nvCxnSpPr>
-          <p:cNvPr id="20" name="Connector 19"/>
+          <p:cNvPr id="19" name="Connector 18"/>
           <p:cNvCxnSpPr/>
           <p:nvPr/>
         </p:nvCxnSpPr>
         <p:spPr>
           <a:xfrm>
-            <a:off x="1412748.0" y="4183380.0"/>
-            <a:ext cx="2839212.0" cy="420624.0"/>
+            <a:off x="6211214" y="2670962"/>
+            <a:ext cx="1225621" cy="526801"/>
           </a:xfrm>
           <a:prstGeom prst="line">
             <a:avLst/>
           </a:prstGeom>
-          <a:ln w="12700">
+          <a:ln w="15875">
             <a:solidFill>
-              <a:srgbClr val="065F46"/>
+              <a:srgbClr val="BF8F00"/>
             </a:solidFill>
           </a:ln>
         </p:spPr>
@@ -4547,26 +4491,29 @@
       </p:cxnSp>
       <p:sp>
         <p:nvSpPr>
-          <p:cNvPr id="21" name="Rounded Rectangle 20"/>
+          <p:cNvPr id="20" name="Rounded Rectangle 19"/>
           <p:cNvSpPr/>
           <p:nvPr/>
         </p:nvSpPr>
         <p:spPr>
           <a:xfrm>
-            <a:off x="2880360" y="4434840"/>
-            <a:ext cx="2743200" cy="338328"/>
+            <a:off x="7436835" y="2921452"/>
+            <a:ext cx="1602292" cy="552622"/>
           </a:xfrm>
           <a:prstGeom prst="roundRect">
-            <a:avLst/>
+            <a:avLst>
+              <a:gd name="adj" fmla="val 50000"/>
+            </a:avLst>
           </a:prstGeom>
           <a:solidFill>
-            <a:srgbClr val="D1FAE5"/>
+            <a:srgbClr val="FFF8E1"/>
           </a:solidFill>
-          <a:ln>
+          <a:ln w="15875">
             <a:solidFill>
-              <a:srgbClr val="D1FAE5"/>
+              <a:srgbClr val="BF8F00"/>
             </a:solidFill>
           </a:ln>
+          <a:effectLst/>
         </p:spPr>
         <p:style>
           <a:lnRef idx="1">
@@ -4583,18 +4530,97 @@
           </a:fontRef>
         </p:style>
         <p:txBody>
-          <a:bodyPr rtlCol="0" anchor="ctr" wrap="square"/>
-          <a:lstStyle/>
-          <a:p>
-            <a:pPr algn="l"/>
-            <a:r>
-              <a:rPr sz="1200" b="0">
-                <a:solidFill>
-                  <a:srgbClr val="022C22"/>
+          <a:bodyPr rtlCol="0" anchor="ctr" wrap="none" lIns="64000" rIns="64000" tIns="25400" bIns="25400"/>
+          <a:lstStyle/>
+          <a:p>
+            <a:pPr algn="ctr"/>
+            <a:r>
+              <a:rPr sz="1300" b="0">
+                <a:solidFill>
+                  <a:srgbClr val="000000"/>
                 </a:solidFill>
                 <a:latin typeface="Calibri"/>
               </a:rPr>
-              <a:t>Lực lượng LĐ vẫn lớn</a:t>
+              <a:t>Lực lượng LĐ vẫn</a:t>
+            </a:r>
+          </a:p>
+          <a:p>
+            <a:pPr algn="ctr"/>
+            <a:r>
+              <a:rPr sz="1300" b="0">
+                <a:solidFill>
+                  <a:srgbClr val="000000"/>
+                </a:solidFill>
+                <a:latin typeface="Calibri"/>
+              </a:rPr>
+              <a:t>lớn</a:t>
+            </a:r>
+          </a:p>
+        </p:txBody>
+      </p:sp>
+      <p:sp>
+        <p:nvSpPr>
+          <p:cNvPr id="21" name="Oval 20"/>
+          <p:cNvSpPr/>
+          <p:nvPr/>
+        </p:nvSpPr>
+        <p:spPr>
+          <a:xfrm>
+            <a:off x="5126095" y="2259078"/>
+            <a:ext cx="2170236" cy="823767"/>
+          </a:xfrm>
+          <a:prstGeom prst="ellipse">
+            <a:avLst/>
+          </a:prstGeom>
+          <a:solidFill>
+            <a:srgbClr val="FFF2CC"/>
+          </a:solidFill>
+          <a:ln w="31750">
+            <a:solidFill>
+              <a:srgbClr val="BF8F00"/>
+            </a:solidFill>
+          </a:ln>
+          <a:effectLst/>
+        </p:spPr>
+        <p:style>
+          <a:lnRef idx="1">
+            <a:schemeClr val="accent1"/>
+          </a:lnRef>
+          <a:fillRef idx="3">
+            <a:schemeClr val="accent1"/>
+          </a:fillRef>
+          <a:effectRef idx="2">
+            <a:schemeClr val="accent1"/>
+          </a:effectRef>
+          <a:fontRef idx="minor">
+            <a:schemeClr val="lt1"/>
+          </a:fontRef>
+        </p:style>
+        <p:txBody>
+          <a:bodyPr rtlCol="0" anchor="ctr" wrap="none" lIns="64000" rIns="64000" tIns="25400" bIns="25400"/>
+          <a:lstStyle/>
+          <a:p>
+            <a:pPr algn="ctr"/>
+            <a:r>
+              <a:rPr sz="1500" b="1">
+                <a:solidFill>
+                  <a:srgbClr val="000000"/>
+                </a:solidFill>
+                <a:latin typeface="Calibri"/>
+              </a:rPr>
+              <a:t>Phân tích tháp</a:t>
+            </a:r>
+          </a:p>
+          <a:p>
+            <a:pPr algn="ctr"/>
+            <a:r>
+              <a:rPr sz="1500" b="1">
+                <a:solidFill>
+                  <a:srgbClr val="000000"/>
+                </a:solidFill>
+                <a:latin typeface="Calibri"/>
+              </a:rPr>
+              <a:t>VN 2023</a:t>
             </a:r>
           </a:p>
         </p:txBody>
@@ -4606,16 +4632,16 @@
           <p:nvPr/>
         </p:nvCxnSpPr>
         <p:spPr>
-          <a:xfrm>
-            <a:off x="6094476.0" y="1124712.0"/>
-            <a:ext cx="4681728.0" cy="864108.0"/>
+          <a:xfrm flipH="1">
+            <a:off x="3508857" y="3954780"/>
+            <a:ext cx="1351179" cy="1283817"/>
           </a:xfrm>
           <a:prstGeom prst="line">
             <a:avLst/>
           </a:prstGeom>
-          <a:ln w="22860">
+          <a:ln w="44450">
             <a:solidFill>
-              <a:srgbClr val="B91C1C"/>
+              <a:srgbClr val="2F5597"/>
             </a:solidFill>
           </a:ln>
         </p:spPr>
@@ -4634,77 +4660,23 @@
           </a:fontRef>
         </p:style>
       </p:cxnSp>
-      <p:sp>
-        <p:nvSpPr>
-          <p:cNvPr id="23" name="Oval 22"/>
-          <p:cNvSpPr/>
-          <p:nvPr/>
-        </p:nvSpPr>
-        <p:spPr>
-          <a:xfrm>
-            <a:off x="9473184" y="1691640"/>
-            <a:ext cx="2606040" cy="594360"/>
-          </a:xfrm>
-          <a:prstGeom prst="ellipse">
-            <a:avLst/>
-          </a:prstGeom>
-          <a:solidFill>
-            <a:srgbClr val="B91C1C"/>
-          </a:solidFill>
-          <a:ln>
-            <a:solidFill>
-              <a:srgbClr val="B91C1C"/>
-            </a:solidFill>
-          </a:ln>
-        </p:spPr>
-        <p:style>
-          <a:lnRef idx="1">
-            <a:schemeClr val="accent1"/>
-          </a:lnRef>
-          <a:fillRef idx="3">
-            <a:schemeClr val="accent1"/>
-          </a:fillRef>
-          <a:effectRef idx="2">
-            <a:schemeClr val="accent1"/>
-          </a:effectRef>
-          <a:fontRef idx="minor">
-            <a:schemeClr val="lt1"/>
-          </a:fontRef>
-        </p:style>
-        <p:txBody>
-          <a:bodyPr rtlCol="0" anchor="ctr" wrap="square"/>
-          <a:lstStyle/>
-          <a:p>
-            <a:pPr algn="ctr"/>
-            <a:r>
-              <a:rPr sz="1300" b="1">
-                <a:solidFill>
-                  <a:srgbClr val="FFFFFF"/>
-                </a:solidFill>
-                <a:latin typeface="Arial"/>
-              </a:rPr>
-              <a:t>Biểu đồ dân số địa phương</a:t>
-            </a:r>
-          </a:p>
-        </p:txBody>
-      </p:sp>
       <p:cxnSp>
         <p:nvCxnSpPr>
-          <p:cNvPr id="24" name="Connector 23"/>
+          <p:cNvPr id="23" name="Connector 22"/>
           <p:cNvCxnSpPr/>
           <p:nvPr/>
         </p:nvCxnSpPr>
         <p:spPr>
           <a:xfrm flipH="1" flipV="1">
-            <a:off x="7936992.0" y="1568196.0"/>
-            <a:ext cx="2839212.0" cy="420624.0"/>
+            <a:off x="2240310" y="4812507"/>
+            <a:ext cx="1268547" cy="426090"/>
           </a:xfrm>
           <a:prstGeom prst="line">
             <a:avLst/>
           </a:prstGeom>
-          <a:ln w="12700">
+          <a:ln w="15875">
             <a:solidFill>
-              <a:srgbClr val="B91C1C"/>
+              <a:srgbClr val="2F5597"/>
             </a:solidFill>
           </a:ln>
         </p:spPr>
@@ -4725,26 +4697,29 @@
       </p:cxnSp>
       <p:sp>
         <p:nvSpPr>
-          <p:cNvPr id="25" name="Rounded Rectangle 24"/>
+          <p:cNvPr id="24" name="Rounded Rectangle 23"/>
           <p:cNvSpPr/>
           <p:nvPr/>
         </p:nvSpPr>
         <p:spPr>
           <a:xfrm>
-            <a:off x="6565392" y="1399032"/>
-            <a:ext cx="2743200" cy="338328"/>
+            <a:off x="723869" y="4636907"/>
+            <a:ext cx="1516440" cy="351200"/>
           </a:xfrm>
           <a:prstGeom prst="roundRect">
-            <a:avLst/>
+            <a:avLst>
+              <a:gd name="adj" fmla="val 50000"/>
+            </a:avLst>
           </a:prstGeom>
           <a:solidFill>
-            <a:srgbClr val="FEE2E2"/>
+            <a:srgbClr val="E3EEF9"/>
           </a:solidFill>
-          <a:ln>
+          <a:ln w="15875">
             <a:solidFill>
-              <a:srgbClr val="FEE2E2"/>
+              <a:srgbClr val="2F5597"/>
             </a:solidFill>
           </a:ln>
+          <a:effectLst/>
         </p:spPr>
         <p:style>
           <a:lnRef idx="1">
@@ -4761,14 +4736,14 @@
           </a:fontRef>
         </p:style>
         <p:txBody>
-          <a:bodyPr rtlCol="0" anchor="ctr" wrap="square"/>
-          <a:lstStyle/>
-          <a:p>
-            <a:pPr algn="l"/>
-            <a:r>
-              <a:rPr sz="1200" b="0">
-                <a:solidFill>
-                  <a:srgbClr val="450A0A"/>
+          <a:bodyPr rtlCol="0" anchor="ctr" wrap="none" lIns="64000" rIns="64000" tIns="25400" bIns="25400"/>
+          <a:lstStyle/>
+          <a:p>
+            <a:pPr algn="ctr"/>
+            <a:r>
+              <a:rPr sz="1300" b="0">
+                <a:solidFill>
+                  <a:srgbClr val="000000"/>
                 </a:solidFill>
                 <a:latin typeface="Calibri"/>
               </a:rPr>
@@ -4779,21 +4754,21 @@
       </p:sp>
       <p:cxnSp>
         <p:nvCxnSpPr>
-          <p:cNvPr id="26" name="Connector 25"/>
+          <p:cNvPr id="25" name="Connector 24"/>
           <p:cNvCxnSpPr/>
           <p:nvPr/>
         </p:nvCxnSpPr>
         <p:spPr>
           <a:xfrm flipH="1">
-            <a:off x="7936992.0" y="1988820.0"/>
-            <a:ext cx="2839212.0" cy="0.0"/>
+            <a:off x="2111532" y="5238597"/>
+            <a:ext cx="1397325" cy="0"/>
           </a:xfrm>
           <a:prstGeom prst="line">
             <a:avLst/>
           </a:prstGeom>
-          <a:ln w="12700">
+          <a:ln w="15875">
             <a:solidFill>
-              <a:srgbClr val="B91C1C"/>
+              <a:srgbClr val="2F5597"/>
             </a:solidFill>
           </a:ln>
         </p:spPr>
@@ -4814,26 +4789,29 @@
       </p:cxnSp>
       <p:sp>
         <p:nvSpPr>
-          <p:cNvPr id="27" name="Rounded Rectangle 26"/>
+          <p:cNvPr id="26" name="Rounded Rectangle 25"/>
           <p:cNvSpPr/>
           <p:nvPr/>
         </p:nvSpPr>
         <p:spPr>
           <a:xfrm>
-            <a:off x="6565392" y="1819656"/>
-            <a:ext cx="2743200" cy="338328"/>
+            <a:off x="852647" y="5062997"/>
+            <a:ext cx="1258884" cy="351200"/>
           </a:xfrm>
           <a:prstGeom prst="roundRect">
-            <a:avLst/>
+            <a:avLst>
+              <a:gd name="adj" fmla="val 50000"/>
+            </a:avLst>
           </a:prstGeom>
           <a:solidFill>
-            <a:srgbClr val="FEE2E2"/>
+            <a:srgbClr val="E3EEF9"/>
           </a:solidFill>
-          <a:ln>
+          <a:ln w="15875">
             <a:solidFill>
-              <a:srgbClr val="FEE2E2"/>
+              <a:srgbClr val="2F5597"/>
             </a:solidFill>
           </a:ln>
+          <a:effectLst/>
         </p:spPr>
         <p:style>
           <a:lnRef idx="1">
@@ -4850,14 +4828,14 @@
           </a:fontRef>
         </p:style>
         <p:txBody>
-          <a:bodyPr rtlCol="0" anchor="ctr" wrap="square"/>
-          <a:lstStyle/>
-          <a:p>
-            <a:pPr algn="l"/>
-            <a:r>
-              <a:rPr sz="1200" b="0">
-                <a:solidFill>
-                  <a:srgbClr val="450A0A"/>
+          <a:bodyPr rtlCol="0" anchor="ctr" wrap="none" lIns="64000" rIns="64000" tIns="25400" bIns="25400"/>
+          <a:lstStyle/>
+          <a:p>
+            <a:pPr algn="ctr"/>
+            <a:r>
+              <a:rPr sz="1300" b="0">
+                <a:solidFill>
+                  <a:srgbClr val="000000"/>
                 </a:solidFill>
                 <a:latin typeface="Calibri"/>
               </a:rPr>
@@ -4868,21 +4846,21 @@
       </p:sp>
       <p:cxnSp>
         <p:nvCxnSpPr>
-          <p:cNvPr id="28" name="Connector 27"/>
+          <p:cNvPr id="27" name="Connector 26"/>
           <p:cNvCxnSpPr/>
           <p:nvPr/>
         </p:nvCxnSpPr>
         <p:spPr>
           <a:xfrm flipH="1">
-            <a:off x="7936992.0" y="1988820.0"/>
-            <a:ext cx="2839212.0" cy="420624.0"/>
+            <a:off x="2197384" y="5238597"/>
+            <a:ext cx="1311473" cy="426090"/>
           </a:xfrm>
           <a:prstGeom prst="line">
             <a:avLst/>
           </a:prstGeom>
-          <a:ln w="12700">
+          <a:ln w="15875">
             <a:solidFill>
-              <a:srgbClr val="B91C1C"/>
+              <a:srgbClr val="2F5597"/>
             </a:solidFill>
           </a:ln>
         </p:spPr>
@@ -4903,26 +4881,29 @@
       </p:cxnSp>
       <p:sp>
         <p:nvSpPr>
-          <p:cNvPr id="29" name="Rounded Rectangle 28"/>
+          <p:cNvPr id="28" name="Rounded Rectangle 27"/>
           <p:cNvSpPr/>
           <p:nvPr/>
         </p:nvSpPr>
         <p:spPr>
           <a:xfrm>
-            <a:off x="6565392" y="2240280"/>
-            <a:ext cx="2743200" cy="338328"/>
+            <a:off x="766795" y="5489087"/>
+            <a:ext cx="1430588" cy="351200"/>
           </a:xfrm>
           <a:prstGeom prst="roundRect">
-            <a:avLst/>
+            <a:avLst>
+              <a:gd name="adj" fmla="val 50000"/>
+            </a:avLst>
           </a:prstGeom>
           <a:solidFill>
-            <a:srgbClr val="FEE2E2"/>
+            <a:srgbClr val="E3EEF9"/>
           </a:solidFill>
-          <a:ln>
+          <a:ln w="15875">
             <a:solidFill>
-              <a:srgbClr val="FEE2E2"/>
+              <a:srgbClr val="2F5597"/>
             </a:solidFill>
           </a:ln>
+          <a:effectLst/>
         </p:spPr>
         <p:style>
           <a:lnRef idx="1">
@@ -4939,18 +4920,85 @@
           </a:fontRef>
         </p:style>
         <p:txBody>
-          <a:bodyPr rtlCol="0" anchor="ctr" wrap="square"/>
-          <a:lstStyle/>
-          <a:p>
-            <a:pPr algn="l"/>
-            <a:r>
-              <a:rPr sz="1200" b="0">
-                <a:solidFill>
-                  <a:srgbClr val="450A0A"/>
+          <a:bodyPr rtlCol="0" anchor="ctr" wrap="none" lIns="64000" rIns="64000" tIns="25400" bIns="25400"/>
+          <a:lstStyle/>
+          <a:p>
+            <a:pPr algn="ctr"/>
+            <a:r>
+              <a:rPr sz="1300" b="0">
+                <a:solidFill>
+                  <a:srgbClr val="000000"/>
                 </a:solidFill>
                 <a:latin typeface="Calibri"/>
               </a:rPr>
               <a:t>So với cả nước</a:t>
+            </a:r>
+          </a:p>
+        </p:txBody>
+      </p:sp>
+      <p:sp>
+        <p:nvSpPr>
+          <p:cNvPr id="29" name="Oval 28"/>
+          <p:cNvSpPr/>
+          <p:nvPr/>
+        </p:nvSpPr>
+        <p:spPr>
+          <a:xfrm>
+            <a:off x="2493081" y="4826713"/>
+            <a:ext cx="2031552" cy="823767"/>
+          </a:xfrm>
+          <a:prstGeom prst="ellipse">
+            <a:avLst/>
+          </a:prstGeom>
+          <a:solidFill>
+            <a:srgbClr val="E2EFDA"/>
+          </a:solidFill>
+          <a:ln w="31750">
+            <a:solidFill>
+              <a:srgbClr val="375623"/>
+            </a:solidFill>
+          </a:ln>
+          <a:effectLst/>
+        </p:spPr>
+        <p:style>
+          <a:lnRef idx="1">
+            <a:schemeClr val="accent1"/>
+          </a:lnRef>
+          <a:fillRef idx="3">
+            <a:schemeClr val="accent1"/>
+          </a:fillRef>
+          <a:effectRef idx="2">
+            <a:schemeClr val="accent1"/>
+          </a:effectRef>
+          <a:fontRef idx="minor">
+            <a:schemeClr val="lt1"/>
+          </a:fontRef>
+        </p:style>
+        <p:txBody>
+          <a:bodyPr rtlCol="0" anchor="ctr" wrap="none" lIns="64000" rIns="64000" tIns="25400" bIns="25400"/>
+          <a:lstStyle/>
+          <a:p>
+            <a:pPr algn="ctr"/>
+            <a:r>
+              <a:rPr sz="1500" b="1">
+                <a:solidFill>
+                  <a:srgbClr val="000000"/>
+                </a:solidFill>
+                <a:latin typeface="Calibri"/>
+              </a:rPr>
+              <a:t>Biểu đồ dân</a:t>
+            </a:r>
+          </a:p>
+          <a:p>
+            <a:pPr algn="ctr"/>
+            <a:r>
+              <a:rPr sz="1500" b="1">
+                <a:solidFill>
+                  <a:srgbClr val="000000"/>
+                </a:solidFill>
+                <a:latin typeface="Calibri"/>
+              </a:rPr>
+              <a:t>số địa phương</a:t>
             </a:r>
           </a:p>
         </p:txBody>
@@ -4963,15 +5011,15 @@
         </p:nvCxnSpPr>
         <p:spPr>
           <a:xfrm>
-            <a:off x="6094476.0" y="1124712.0"/>
-            <a:ext cx="4681728.0" cy="3058668.0"/>
+            <a:off x="4860036" y="3954780"/>
+            <a:ext cx="1351178" cy="1283817"/>
           </a:xfrm>
           <a:prstGeom prst="line">
             <a:avLst/>
           </a:prstGeom>
-          <a:ln w="22860">
+          <a:ln w="44450">
             <a:solidFill>
-              <a:srgbClr val="B45309"/>
+              <a:srgbClr val="7030A0"/>
             </a:solidFill>
           </a:ln>
         </p:spPr>
@@ -4990,77 +5038,23 @@
           </a:fontRef>
         </p:style>
       </p:cxnSp>
-      <p:sp>
-        <p:nvSpPr>
-          <p:cNvPr id="31" name="Oval 30"/>
-          <p:cNvSpPr/>
-          <p:nvPr/>
-        </p:nvSpPr>
-        <p:spPr>
-          <a:xfrm>
-            <a:off x="9473184" y="3886200"/>
-            <a:ext cx="2606040" cy="594360"/>
-          </a:xfrm>
-          <a:prstGeom prst="ellipse">
-            <a:avLst/>
-          </a:prstGeom>
-          <a:solidFill>
-            <a:srgbClr val="B45309"/>
-          </a:solidFill>
-          <a:ln>
-            <a:solidFill>
-              <a:srgbClr val="B45309"/>
-            </a:solidFill>
-          </a:ln>
-        </p:spPr>
-        <p:style>
-          <a:lnRef idx="1">
-            <a:schemeClr val="accent1"/>
-          </a:lnRef>
-          <a:fillRef idx="3">
-            <a:schemeClr val="accent1"/>
-          </a:fillRef>
-          <a:effectRef idx="2">
-            <a:schemeClr val="accent1"/>
-          </a:effectRef>
-          <a:fontRef idx="minor">
-            <a:schemeClr val="lt1"/>
-          </a:fontRef>
-        </p:style>
-        <p:txBody>
-          <a:bodyPr rtlCol="0" anchor="ctr" wrap="square"/>
-          <a:lstStyle/>
-          <a:p>
-            <a:pPr algn="ctr"/>
-            <a:r>
-              <a:rPr sz="1300" b="1">
-                <a:solidFill>
-                  <a:srgbClr val="FFFFFF"/>
-                </a:solidFill>
-                <a:latin typeface="Arial"/>
-              </a:rPr>
-              <a:t>Liên hệ Bình Định</a:t>
-            </a:r>
-          </a:p>
-        </p:txBody>
-      </p:sp>
       <p:cxnSp>
         <p:nvCxnSpPr>
-          <p:cNvPr id="32" name="Connector 31"/>
+          <p:cNvPr id="31" name="Connector 30"/>
           <p:cNvCxnSpPr/>
           <p:nvPr/>
         </p:nvCxnSpPr>
         <p:spPr>
-          <a:xfrm flipH="1" flipV="1">
-            <a:off x="7936992.0" y="3762756.0"/>
-            <a:ext cx="2839212.0" cy="420624.0"/>
+          <a:xfrm flipV="1">
+            <a:off x="6211214" y="4711796"/>
+            <a:ext cx="1354399" cy="526801"/>
           </a:xfrm>
           <a:prstGeom prst="line">
             <a:avLst/>
           </a:prstGeom>
-          <a:ln w="12700">
+          <a:ln w="15875">
             <a:solidFill>
-              <a:srgbClr val="B45309"/>
+              <a:srgbClr val="7030A0"/>
             </a:solidFill>
           </a:ln>
         </p:spPr>
@@ -5081,26 +5075,29 @@
       </p:cxnSp>
       <p:sp>
         <p:nvSpPr>
-          <p:cNvPr id="33" name="Rounded Rectangle 32"/>
+          <p:cNvPr id="32" name="Rounded Rectangle 31"/>
           <p:cNvSpPr/>
           <p:nvPr/>
         </p:nvSpPr>
         <p:spPr>
           <a:xfrm>
-            <a:off x="6565392" y="3593592"/>
-            <a:ext cx="2743200" cy="338328"/>
+            <a:off x="7565613" y="4536196"/>
+            <a:ext cx="1344736" cy="351200"/>
           </a:xfrm>
           <a:prstGeom prst="roundRect">
-            <a:avLst/>
+            <a:avLst>
+              <a:gd name="adj" fmla="val 50000"/>
+            </a:avLst>
           </a:prstGeom>
           <a:solidFill>
-            <a:srgbClr val="FEF3C7"/>
+            <a:srgbClr val="F3E8F7"/>
           </a:solidFill>
-          <a:ln>
+          <a:ln w="15875">
             <a:solidFill>
-              <a:srgbClr val="FEF3C7"/>
+              <a:srgbClr val="7030A0"/>
             </a:solidFill>
           </a:ln>
+          <a:effectLst/>
         </p:spPr>
         <p:style>
           <a:lnRef idx="1">
@@ -5117,14 +5114,14 @@
           </a:fontRef>
         </p:style>
         <p:txBody>
-          <a:bodyPr rtlCol="0" anchor="ctr" wrap="square"/>
-          <a:lstStyle/>
-          <a:p>
-            <a:pPr algn="l"/>
-            <a:r>
-              <a:rPr sz="1200" b="0">
-                <a:solidFill>
-                  <a:srgbClr val="451A03"/>
+          <a:bodyPr rtlCol="0" anchor="ctr" wrap="none" lIns="64000" rIns="64000" tIns="25400" bIns="25400"/>
+          <a:lstStyle/>
+          <a:p>
+            <a:pPr algn="ctr"/>
+            <a:r>
+              <a:rPr sz="1300" b="0">
+                <a:solidFill>
+                  <a:srgbClr val="000000"/>
                 </a:solidFill>
                 <a:latin typeface="Calibri"/>
               </a:rPr>
@@ -5135,21 +5132,21 @@
       </p:sp>
       <p:cxnSp>
         <p:nvCxnSpPr>
-          <p:cNvPr id="34" name="Connector 33"/>
+          <p:cNvPr id="33" name="Connector 32"/>
           <p:cNvCxnSpPr/>
           <p:nvPr/>
         </p:nvCxnSpPr>
         <p:spPr>
-          <a:xfrm flipH="1">
-            <a:off x="7936992.0" y="4183380.0"/>
-            <a:ext cx="2839212.0" cy="0.0"/>
+          <a:xfrm flipV="1">
+            <a:off x="6211214" y="5137886"/>
+            <a:ext cx="1440251" cy="100711"/>
           </a:xfrm>
           <a:prstGeom prst="line">
             <a:avLst/>
           </a:prstGeom>
-          <a:ln w="12700">
+          <a:ln w="15875">
             <a:solidFill>
-              <a:srgbClr val="B45309"/>
+              <a:srgbClr val="7030A0"/>
             </a:solidFill>
           </a:ln>
         </p:spPr>
@@ -5170,26 +5167,29 @@
       </p:cxnSp>
       <p:sp>
         <p:nvSpPr>
-          <p:cNvPr id="35" name="Rounded Rectangle 34"/>
+          <p:cNvPr id="34" name="Rounded Rectangle 33"/>
           <p:cNvSpPr/>
           <p:nvPr/>
         </p:nvSpPr>
         <p:spPr>
           <a:xfrm>
-            <a:off x="6565392" y="4014216"/>
-            <a:ext cx="2743200" cy="338328"/>
+            <a:off x="7651465" y="4962286"/>
+            <a:ext cx="1173032" cy="351200"/>
           </a:xfrm>
           <a:prstGeom prst="roundRect">
-            <a:avLst/>
+            <a:avLst>
+              <a:gd name="adj" fmla="val 50000"/>
+            </a:avLst>
           </a:prstGeom>
           <a:solidFill>
-            <a:srgbClr val="FEF3C7"/>
+            <a:srgbClr val="F3E8F7"/>
           </a:solidFill>
-          <a:ln>
+          <a:ln w="15875">
             <a:solidFill>
-              <a:srgbClr val="FEF3C7"/>
+              <a:srgbClr val="7030A0"/>
             </a:solidFill>
           </a:ln>
+          <a:effectLst/>
         </p:spPr>
         <p:style>
           <a:lnRef idx="1">
@@ -5206,14 +5206,14 @@
           </a:fontRef>
         </p:style>
         <p:txBody>
-          <a:bodyPr rtlCol="0" anchor="ctr" wrap="square"/>
-          <a:lstStyle/>
-          <a:p>
-            <a:pPr algn="l"/>
-            <a:r>
-              <a:rPr sz="1200" b="0">
-                <a:solidFill>
-                  <a:srgbClr val="451A03"/>
+          <a:bodyPr rtlCol="0" anchor="ctr" wrap="none" lIns="64000" rIns="64000" tIns="25400" bIns="25400"/>
+          <a:lstStyle/>
+          <a:p>
+            <a:pPr algn="ctr"/>
+            <a:r>
+              <a:rPr sz="1300" b="0">
+                <a:solidFill>
+                  <a:srgbClr val="000000"/>
                 </a:solidFill>
                 <a:latin typeface="Calibri"/>
               </a:rPr>
@@ -5224,21 +5224,21 @@
       </p:sp>
       <p:cxnSp>
         <p:nvCxnSpPr>
-          <p:cNvPr id="36" name="Connector 35"/>
+          <p:cNvPr id="35" name="Connector 34"/>
           <p:cNvCxnSpPr/>
           <p:nvPr/>
         </p:nvCxnSpPr>
         <p:spPr>
-          <a:xfrm flipH="1">
-            <a:off x="7936992.0" y="4183380.0"/>
-            <a:ext cx="2839212.0" cy="420624.0"/>
+          <a:xfrm>
+            <a:off x="6211214" y="5238597"/>
+            <a:ext cx="1182695" cy="426090"/>
           </a:xfrm>
           <a:prstGeom prst="line">
             <a:avLst/>
           </a:prstGeom>
-          <a:ln w="12700">
+          <a:ln w="15875">
             <a:solidFill>
-              <a:srgbClr val="B45309"/>
+              <a:srgbClr val="7030A0"/>
             </a:solidFill>
           </a:ln>
         </p:spPr>
@@ -5259,26 +5259,29 @@
       </p:cxnSp>
       <p:sp>
         <p:nvSpPr>
-          <p:cNvPr id="37" name="Rounded Rectangle 36"/>
+          <p:cNvPr id="36" name="Rounded Rectangle 35"/>
           <p:cNvSpPr/>
           <p:nvPr/>
         </p:nvSpPr>
         <p:spPr>
           <a:xfrm>
-            <a:off x="6565392" y="4434840"/>
-            <a:ext cx="2743200" cy="338328"/>
+            <a:off x="7393909" y="5388376"/>
+            <a:ext cx="1688144" cy="552622"/>
           </a:xfrm>
           <a:prstGeom prst="roundRect">
-            <a:avLst/>
+            <a:avLst>
+              <a:gd name="adj" fmla="val 50000"/>
+            </a:avLst>
           </a:prstGeom>
           <a:solidFill>
-            <a:srgbClr val="FEF3C7"/>
+            <a:srgbClr val="F3E8F7"/>
           </a:solidFill>
-          <a:ln>
+          <a:ln w="15875">
             <a:solidFill>
-              <a:srgbClr val="FEF3C7"/>
+              <a:srgbClr val="7030A0"/>
             </a:solidFill>
           </a:ln>
+          <a:effectLst/>
         </p:spPr>
         <p:style>
           <a:lnRef idx="1">
@@ -5295,18 +5298,176 @@
           </a:fontRef>
         </p:style>
         <p:txBody>
-          <a:bodyPr rtlCol="0" anchor="ctr" wrap="square"/>
-          <a:lstStyle/>
-          <a:p>
-            <a:pPr algn="l"/>
-            <a:r>
-              <a:rPr sz="1200" b="0">
-                <a:solidFill>
-                  <a:srgbClr val="451A03"/>
+          <a:bodyPr rtlCol="0" anchor="ctr" wrap="none" lIns="64000" rIns="64000" tIns="25400" bIns="25400"/>
+          <a:lstStyle/>
+          <a:p>
+            <a:pPr algn="ctr"/>
+            <a:r>
+              <a:rPr sz="1300" b="0">
+                <a:solidFill>
+                  <a:srgbClr val="000000"/>
                 </a:solidFill>
                 <a:latin typeface="Calibri"/>
               </a:rPr>
-              <a:t>Vĩnh Thạnh 25 000 người</a:t>
+              <a:t>địa phương 25 000</a:t>
+            </a:r>
+          </a:p>
+          <a:p>
+            <a:pPr algn="ctr"/>
+            <a:r>
+              <a:rPr sz="1300" b="0">
+                <a:solidFill>
+                  <a:srgbClr val="000000"/>
+                </a:solidFill>
+                <a:latin typeface="Calibri"/>
+              </a:rPr>
+              <a:t>người</a:t>
+            </a:r>
+          </a:p>
+        </p:txBody>
+      </p:sp>
+      <p:sp>
+        <p:nvSpPr>
+          <p:cNvPr id="37" name="Oval 36"/>
+          <p:cNvSpPr/>
+          <p:nvPr/>
+        </p:nvSpPr>
+        <p:spPr>
+          <a:xfrm>
+            <a:off x="5264779" y="4826713"/>
+            <a:ext cx="1892868" cy="823767"/>
+          </a:xfrm>
+          <a:prstGeom prst="ellipse">
+            <a:avLst/>
+          </a:prstGeom>
+          <a:solidFill>
+            <a:srgbClr val="FFF2CC"/>
+          </a:solidFill>
+          <a:ln w="31750">
+            <a:solidFill>
+              <a:srgbClr val="BF8F00"/>
+            </a:solidFill>
+          </a:ln>
+          <a:effectLst/>
+        </p:spPr>
+        <p:style>
+          <a:lnRef idx="1">
+            <a:schemeClr val="accent1"/>
+          </a:lnRef>
+          <a:fillRef idx="3">
+            <a:schemeClr val="accent1"/>
+          </a:fillRef>
+          <a:effectRef idx="2">
+            <a:schemeClr val="accent1"/>
+          </a:effectRef>
+          <a:fontRef idx="minor">
+            <a:schemeClr val="lt1"/>
+          </a:fontRef>
+        </p:style>
+        <p:txBody>
+          <a:bodyPr rtlCol="0" anchor="ctr" wrap="none" lIns="64000" rIns="64000" tIns="25400" bIns="25400"/>
+          <a:lstStyle/>
+          <a:p>
+            <a:pPr algn="ctr"/>
+            <a:r>
+              <a:rPr sz="1500" b="1">
+                <a:solidFill>
+                  <a:srgbClr val="000000"/>
+                </a:solidFill>
+                <a:latin typeface="Calibri"/>
+              </a:rPr>
+              <a:t>Liên hệ Bình</a:t>
+            </a:r>
+          </a:p>
+          <a:p>
+            <a:pPr algn="ctr"/>
+            <a:r>
+              <a:rPr sz="1500" b="1">
+                <a:solidFill>
+                  <a:srgbClr val="000000"/>
+                </a:solidFill>
+                <a:latin typeface="Calibri"/>
+              </a:rPr>
+              <a:t>Định</a:t>
+            </a:r>
+          </a:p>
+        </p:txBody>
+      </p:sp>
+      <p:sp>
+        <p:nvSpPr>
+          <p:cNvPr id="38" name="Oval 37"/>
+          <p:cNvSpPr/>
+          <p:nvPr/>
+        </p:nvSpPr>
+        <p:spPr>
+          <a:xfrm>
+            <a:off x="3802654" y="3287245"/>
+            <a:ext cx="2114763" cy="1335069"/>
+          </a:xfrm>
+          <a:prstGeom prst="ellipse">
+            <a:avLst/>
+          </a:prstGeom>
+          <a:solidFill>
+            <a:srgbClr val="002060"/>
+          </a:solidFill>
+          <a:ln w="25400">
+            <a:solidFill>
+              <a:srgbClr val="000B1E"/>
+            </a:solidFill>
+          </a:ln>
+          <a:effectLst/>
+        </p:spPr>
+        <p:style>
+          <a:lnRef idx="1">
+            <a:schemeClr val="accent1"/>
+          </a:lnRef>
+          <a:fillRef idx="3">
+            <a:schemeClr val="accent1"/>
+          </a:fillRef>
+          <a:effectRef idx="2">
+            <a:schemeClr val="accent1"/>
+          </a:effectRef>
+          <a:fontRef idx="minor">
+            <a:schemeClr val="lt1"/>
+          </a:fontRef>
+        </p:style>
+        <p:txBody>
+          <a:bodyPr rtlCol="0" anchor="ctr" wrap="none" lIns="64000" rIns="64000" tIns="25400" bIns="25400"/>
+          <a:lstStyle/>
+          <a:p>
+            <a:pPr algn="ctr"/>
+            <a:r>
+              <a:rPr sz="1700" b="1">
+                <a:solidFill>
+                  <a:srgbClr val="FFFFFF"/>
+                </a:solidFill>
+                <a:latin typeface="Calibri"/>
+              </a:rPr>
+              <a:t>BÀI 10 (TH).</a:t>
+            </a:r>
+          </a:p>
+          <a:p>
+            <a:pPr algn="ctr"/>
+            <a:r>
+              <a:rPr sz="1700" b="1">
+                <a:solidFill>
+                  <a:srgbClr val="FFFFFF"/>
+                </a:solidFill>
+                <a:latin typeface="Calibri"/>
+              </a:rPr>
+              <a:t>BÁO CÁO DÂN</a:t>
+            </a:r>
+          </a:p>
+          <a:p>
+            <a:pPr algn="ctr"/>
+            <a:r>
+              <a:rPr sz="1700" b="1">
+                <a:solidFill>
+                  <a:srgbClr val="FFFFFF"/>
+                </a:solidFill>
+                <a:latin typeface="Calibri"/>
+              </a:rPr>
+              <a:t>CƯ</a:t>
             </a:r>
           </a:p>
         </p:txBody>
@@ -6496,7 +6657,7 @@
                 </a:solidFill>
                 <a:latin typeface="Arial"/>
               </a:rPr>
-              <a:t>✦ Bình Định: 1,3 triệu dân; Vĩnh Thạnh ~25 000</a:t>
+              <a:t>✦ Bình Định: 1,3 triệu dân; địa phương ~25 000</a:t>
             </a:r>
           </a:p>
         </p:txBody>
@@ -6886,7 +7047,7 @@
                 </a:solidFill>
                 <a:latin typeface="Calibri"/>
               </a:rPr>
-              <a:t>Chúc các em học tốt! – THPT Vĩnh Thạnh</a:t>
+              <a:t>Chúc các em học tốt! – Trường THPT</a:t>
             </a:r>
           </a:p>
         </p:txBody>

</xml_diff>